<commit_message>
Module 1: use plain t-test, drop effect-size measures (notebook + slide)
</commit_message>
<xml_diff>
--- a/Integrated Data Analytics Exercise/slides/MADT6004_Wrap_Up_Session.pptx
+++ b/Integrated Data Analytics Exercise/slides/MADT6004_Wrap_Up_Session.pptx
@@ -22288,65 +22288,6 @@
       </p:sp>
       <p:sp>
         <p:nvSpPr>
-          <p:cNvPr id="13" name="Shape 11"/>
-          <p:cNvSpPr/>
-          <p:nvPr/>
-        </p:nvSpPr>
-        <p:spPr>
-          <a:xfrm>
-            <a:off x="5760720" y="1280160"/>
-            <a:ext cx="2286000" cy="365760"/>
-          </a:xfrm>
-          <a:prstGeom prst="rect">
-            <a:avLst/>
-          </a:prstGeom>
-          <a:solidFill>
-            <a:srgbClr val="0891B2"/>
-          </a:solidFill>
-          <a:ln/>
-        </p:spPr>
-      </p:sp>
-      <p:sp>
-        <p:nvSpPr>
-          <p:cNvPr id="14" name="Text 12"/>
-          <p:cNvSpPr/>
-          <p:nvPr/>
-        </p:nvSpPr>
-        <p:spPr>
-          <a:xfrm>
-            <a:off x="5760720" y="1280160"/>
-            <a:ext cx="2286000" cy="365760"/>
-          </a:xfrm>
-          <a:prstGeom prst="rect">
-            <a:avLst/>
-          </a:prstGeom>
-          <a:noFill/>
-          <a:ln/>
-        </p:spPr>
-        <p:txBody>
-          <a:bodyPr wrap="square" lIns="0" tIns="0" rIns="0" bIns="0" rtlCol="0" anchor="ctr"/>
-          <a:lstStyle/>
-          <a:p>
-            <a:pPr algn="ctr" indent="0" marL="0">
-              <a:buNone/>
-            </a:pPr>
-            <a:r>
-              <a:rPr lang="en-US" sz="1100" b="1" dirty="0">
-                <a:solidFill>
-                  <a:srgbClr val="FFFFFF"/>
-                </a:solidFill>
-                <a:latin typeface="Arial" pitchFamily="34" charset="0"/>
-                <a:ea typeface="Arial" pitchFamily="34" charset="-122"/>
-                <a:cs typeface="Arial" pitchFamily="34" charset="-120"/>
-              </a:rPr>
-              <a:t>Effect-size measure</a:t>
-            </a:r>
-            <a:endParaRPr lang="en-US" sz="1100" dirty="0"/>
-          </a:p>
-        </p:txBody>
-      </p:sp>
-      <p:sp>
-        <p:nvSpPr>
           <p:cNvPr id="15" name="Shape 13"/>
           <p:cNvSpPr/>
           <p:nvPr/>
@@ -22531,7 +22472,7 @@
                 <a:ea typeface="Arial" pitchFamily="34" charset="-122"/>
                 <a:cs typeface="Arial" pitchFamily="34" charset="-120"/>
               </a:rPr>
-              <a:t>Welch's t-test</a:t>
+              <a:t>t-test</a:t>
             </a:r>
             <a:endParaRPr lang="en-US" sz="1100" dirty="0"/>
           </a:p>
@@ -22539,14 +22480,206 @@
       </p:sp>
       <p:sp>
         <p:nvSpPr>
-          <p:cNvPr id="21" name="Shape 19"/>
-          <p:cNvSpPr/>
-          <p:nvPr/>
-        </p:nvSpPr>
-        <p:spPr>
-          <a:xfrm>
-            <a:off x="5760720" y="1645920"/>
+          <p:cNvPr id="23" name="Shape 21"/>
+          <p:cNvSpPr/>
+          <p:nvPr/>
+        </p:nvSpPr>
+        <p:spPr>
+          <a:xfrm>
+            <a:off x="640080" y="2011680"/>
+            <a:ext cx="1371600" cy="365760"/>
+          </a:xfrm>
+          <a:prstGeom prst="rect">
+            <a:avLst/>
+          </a:prstGeom>
+          <a:solidFill>
+            <a:srgbClr val="F3F4F6"/>
+          </a:solidFill>
+          <a:ln w="6350">
+            <a:solidFill>
+              <a:srgbClr val="D1D5DB"/>
+            </a:solidFill>
+            <a:prstDash val="solid"/>
+          </a:ln>
+        </p:spPr>
+      </p:sp>
+      <p:sp>
+        <p:nvSpPr>
+          <p:cNvPr id="24" name="Text 22"/>
+          <p:cNvSpPr/>
+          <p:nvPr/>
+        </p:nvSpPr>
+        <p:spPr>
+          <a:xfrm>
+            <a:off x="685800" y="2011680"/>
+            <a:ext cx="1280160" cy="365760"/>
+          </a:xfrm>
+          <a:prstGeom prst="rect">
+            <a:avLst/>
+          </a:prstGeom>
+          <a:noFill/>
+          <a:ln/>
+        </p:spPr>
+        <p:txBody>
+          <a:bodyPr wrap="square" lIns="0" tIns="0" rIns="0" bIns="0" rtlCol="0" anchor="ctr"/>
+          <a:lstStyle/>
+          <a:p>
+            <a:pPr indent="0" marL="0">
+              <a:buNone/>
+            </a:pPr>
+            <a:r>
+              <a:rPr lang="en-US" sz="1100" dirty="0">
+                <a:solidFill>
+                  <a:srgbClr val="374151"/>
+                </a:solidFill>
+                <a:latin typeface="Arial" pitchFamily="34" charset="0"/>
+                <a:ea typeface="Arial" pitchFamily="34" charset="-122"/>
+                <a:cs typeface="Arial" pitchFamily="34" charset="-120"/>
+              </a:rPr>
+              <a:t>categorical</a:t>
+            </a:r>
+            <a:endParaRPr lang="en-US" sz="1100" dirty="0"/>
+          </a:p>
+        </p:txBody>
+      </p:sp>
+      <p:sp>
+        <p:nvSpPr>
+          <p:cNvPr id="25" name="Shape 23"/>
+          <p:cNvSpPr/>
+          <p:nvPr/>
+        </p:nvSpPr>
+        <p:spPr>
+          <a:xfrm>
+            <a:off x="2011680" y="2011680"/>
+            <a:ext cx="1371600" cy="365760"/>
+          </a:xfrm>
+          <a:prstGeom prst="rect">
+            <a:avLst/>
+          </a:prstGeom>
+          <a:solidFill>
+            <a:srgbClr val="F3F4F6"/>
+          </a:solidFill>
+          <a:ln w="6350">
+            <a:solidFill>
+              <a:srgbClr val="D1D5DB"/>
+            </a:solidFill>
+            <a:prstDash val="solid"/>
+          </a:ln>
+        </p:spPr>
+      </p:sp>
+      <p:sp>
+        <p:nvSpPr>
+          <p:cNvPr id="26" name="Text 24"/>
+          <p:cNvSpPr/>
+          <p:nvPr/>
+        </p:nvSpPr>
+        <p:spPr>
+          <a:xfrm>
+            <a:off x="2057400" y="2011680"/>
+            <a:ext cx="1280160" cy="365760"/>
+          </a:xfrm>
+          <a:prstGeom prst="rect">
+            <a:avLst/>
+          </a:prstGeom>
+          <a:noFill/>
+          <a:ln/>
+        </p:spPr>
+        <p:txBody>
+          <a:bodyPr wrap="square" lIns="0" tIns="0" rIns="0" bIns="0" rtlCol="0" anchor="ctr"/>
+          <a:lstStyle/>
+          <a:p>
+            <a:pPr indent="0" marL="0">
+              <a:buNone/>
+            </a:pPr>
+            <a:r>
+              <a:rPr lang="en-US" sz="1100" dirty="0">
+                <a:solidFill>
+                  <a:srgbClr val="374151"/>
+                </a:solidFill>
+                <a:latin typeface="Arial" pitchFamily="34" charset="0"/>
+                <a:ea typeface="Arial" pitchFamily="34" charset="-122"/>
+                <a:cs typeface="Arial" pitchFamily="34" charset="-120"/>
+              </a:rPr>
+              <a:t>continuous</a:t>
+            </a:r>
+            <a:endParaRPr lang="en-US" sz="1100" dirty="0"/>
+          </a:p>
+        </p:txBody>
+      </p:sp>
+      <p:sp>
+        <p:nvSpPr>
+          <p:cNvPr id="27" name="Shape 25"/>
+          <p:cNvSpPr/>
+          <p:nvPr/>
+        </p:nvSpPr>
+        <p:spPr>
+          <a:xfrm>
+            <a:off x="3383280" y="2011680"/>
+            <a:ext cx="2377440" cy="365760"/>
+          </a:xfrm>
+          <a:prstGeom prst="rect">
+            <a:avLst/>
+          </a:prstGeom>
+          <a:solidFill>
+            <a:srgbClr val="F3F4F6"/>
+          </a:solidFill>
+          <a:ln w="6350">
+            <a:solidFill>
+              <a:srgbClr val="D1D5DB"/>
+            </a:solidFill>
+            <a:prstDash val="solid"/>
+          </a:ln>
+        </p:spPr>
+      </p:sp>
+      <p:sp>
+        <p:nvSpPr>
+          <p:cNvPr id="28" name="Text 26"/>
+          <p:cNvSpPr/>
+          <p:nvPr/>
+        </p:nvSpPr>
+        <p:spPr>
+          <a:xfrm>
+            <a:off x="3429000" y="2011680"/>
             <a:ext cx="2286000" cy="365760"/>
+          </a:xfrm>
+          <a:prstGeom prst="rect">
+            <a:avLst/>
+          </a:prstGeom>
+          <a:noFill/>
+          <a:ln/>
+        </p:spPr>
+        <p:txBody>
+          <a:bodyPr wrap="square" lIns="0" tIns="0" rIns="0" bIns="0" rtlCol="0" anchor="ctr"/>
+          <a:lstStyle/>
+          <a:p>
+            <a:pPr indent="0" marL="0">
+              <a:buNone/>
+            </a:pPr>
+            <a:r>
+              <a:rPr lang="en-US" sz="1100" dirty="0">
+                <a:solidFill>
+                  <a:srgbClr val="374151"/>
+                </a:solidFill>
+                <a:latin typeface="Arial" pitchFamily="34" charset="0"/>
+                <a:ea typeface="Arial" pitchFamily="34" charset="-122"/>
+                <a:cs typeface="Arial" pitchFamily="34" charset="-120"/>
+              </a:rPr>
+              <a:t>One-way ANOVA</a:t>
+            </a:r>
+            <a:endParaRPr lang="en-US" sz="1100" dirty="0"/>
+          </a:p>
+        </p:txBody>
+      </p:sp>
+      <p:sp>
+        <p:nvSpPr>
+          <p:cNvPr id="31" name="Shape 29"/>
+          <p:cNvSpPr/>
+          <p:nvPr/>
+        </p:nvSpPr>
+        <p:spPr>
+          <a:xfrm>
+            <a:off x="640080" y="2377440"/>
+            <a:ext cx="1371600" cy="365760"/>
           </a:xfrm>
           <a:prstGeom prst="rect">
             <a:avLst/>
@@ -22564,14 +22697,14 @@
       </p:sp>
       <p:sp>
         <p:nvSpPr>
-          <p:cNvPr id="22" name="Text 20"/>
-          <p:cNvSpPr/>
-          <p:nvPr/>
-        </p:nvSpPr>
-        <p:spPr>
-          <a:xfrm>
-            <a:off x="5806440" y="1645920"/>
-            <a:ext cx="2194560" cy="365760"/>
+          <p:cNvPr id="32" name="Text 30"/>
+          <p:cNvSpPr/>
+          <p:nvPr/>
+        </p:nvSpPr>
+        <p:spPr>
+          <a:xfrm>
+            <a:off x="685800" y="2377440"/>
+            <a:ext cx="1280160" cy="365760"/>
           </a:xfrm>
           <a:prstGeom prst="rect">
             <a:avLst/>
@@ -22595,7 +22728,7 @@
                 <a:ea typeface="Arial" pitchFamily="34" charset="-122"/>
                 <a:cs typeface="Arial" pitchFamily="34" charset="-120"/>
               </a:rPr>
-              <a:t>Cohen's d</a:t>
+              <a:t>continuous</a:t>
             </a:r>
             <a:endParaRPr lang="en-US" sz="1100" dirty="0"/>
           </a:p>
@@ -22603,13 +22736,141 @@
       </p:sp>
       <p:sp>
         <p:nvSpPr>
-          <p:cNvPr id="23" name="Shape 21"/>
-          <p:cNvSpPr/>
-          <p:nvPr/>
-        </p:nvSpPr>
-        <p:spPr>
-          <a:xfrm>
-            <a:off x="640080" y="2011680"/>
+          <p:cNvPr id="33" name="Shape 31"/>
+          <p:cNvSpPr/>
+          <p:nvPr/>
+        </p:nvSpPr>
+        <p:spPr>
+          <a:xfrm>
+            <a:off x="2011680" y="2377440"/>
+            <a:ext cx="1371600" cy="365760"/>
+          </a:xfrm>
+          <a:prstGeom prst="rect">
+            <a:avLst/>
+          </a:prstGeom>
+          <a:solidFill>
+            <a:srgbClr val="FFFFFF"/>
+          </a:solidFill>
+          <a:ln w="6350">
+            <a:solidFill>
+              <a:srgbClr val="D1D5DB"/>
+            </a:solidFill>
+            <a:prstDash val="solid"/>
+          </a:ln>
+        </p:spPr>
+      </p:sp>
+      <p:sp>
+        <p:nvSpPr>
+          <p:cNvPr id="34" name="Text 32"/>
+          <p:cNvSpPr/>
+          <p:nvPr/>
+        </p:nvSpPr>
+        <p:spPr>
+          <a:xfrm>
+            <a:off x="2057400" y="2377440"/>
+            <a:ext cx="1280160" cy="365760"/>
+          </a:xfrm>
+          <a:prstGeom prst="rect">
+            <a:avLst/>
+          </a:prstGeom>
+          <a:noFill/>
+          <a:ln/>
+        </p:spPr>
+        <p:txBody>
+          <a:bodyPr wrap="square" lIns="0" tIns="0" rIns="0" bIns="0" rtlCol="0" anchor="ctr"/>
+          <a:lstStyle/>
+          <a:p>
+            <a:pPr indent="0" marL="0">
+              <a:buNone/>
+            </a:pPr>
+            <a:r>
+              <a:rPr lang="en-US" sz="1100" dirty="0">
+                <a:solidFill>
+                  <a:srgbClr val="374151"/>
+                </a:solidFill>
+                <a:latin typeface="Arial" pitchFamily="34" charset="0"/>
+                <a:ea typeface="Arial" pitchFamily="34" charset="-122"/>
+                <a:cs typeface="Arial" pitchFamily="34" charset="-120"/>
+              </a:rPr>
+              <a:t>continuous</a:t>
+            </a:r>
+            <a:endParaRPr lang="en-US" sz="1100" dirty="0"/>
+          </a:p>
+        </p:txBody>
+      </p:sp>
+      <p:sp>
+        <p:nvSpPr>
+          <p:cNvPr id="35" name="Shape 33"/>
+          <p:cNvSpPr/>
+          <p:nvPr/>
+        </p:nvSpPr>
+        <p:spPr>
+          <a:xfrm>
+            <a:off x="3383280" y="2377440"/>
+            <a:ext cx="2377440" cy="365760"/>
+          </a:xfrm>
+          <a:prstGeom prst="rect">
+            <a:avLst/>
+          </a:prstGeom>
+          <a:solidFill>
+            <a:srgbClr val="FFFFFF"/>
+          </a:solidFill>
+          <a:ln w="6350">
+            <a:solidFill>
+              <a:srgbClr val="D1D5DB"/>
+            </a:solidFill>
+            <a:prstDash val="solid"/>
+          </a:ln>
+        </p:spPr>
+      </p:sp>
+      <p:sp>
+        <p:nvSpPr>
+          <p:cNvPr id="36" name="Text 34"/>
+          <p:cNvSpPr/>
+          <p:nvPr/>
+        </p:nvSpPr>
+        <p:spPr>
+          <a:xfrm>
+            <a:off x="3429000" y="2377440"/>
+            <a:ext cx="2286000" cy="365760"/>
+          </a:xfrm>
+          <a:prstGeom prst="rect">
+            <a:avLst/>
+          </a:prstGeom>
+          <a:noFill/>
+          <a:ln/>
+        </p:spPr>
+        <p:txBody>
+          <a:bodyPr wrap="square" lIns="0" tIns="0" rIns="0" bIns="0" rtlCol="0" anchor="ctr"/>
+          <a:lstStyle/>
+          <a:p>
+            <a:pPr indent="0" marL="0">
+              <a:buNone/>
+            </a:pPr>
+            <a:r>
+              <a:rPr lang="en-US" sz="1100" dirty="0">
+                <a:solidFill>
+                  <a:srgbClr val="374151"/>
+                </a:solidFill>
+                <a:latin typeface="Arial" pitchFamily="34" charset="0"/>
+                <a:ea typeface="Arial" pitchFamily="34" charset="-122"/>
+                <a:cs typeface="Arial" pitchFamily="34" charset="-120"/>
+              </a:rPr>
+              <a:t>Pearson correlation</a:t>
+            </a:r>
+            <a:endParaRPr lang="en-US" sz="1100" dirty="0"/>
+          </a:p>
+        </p:txBody>
+      </p:sp>
+      <p:sp>
+        <p:nvSpPr>
+          <p:cNvPr id="39" name="Shape 37"/>
+          <p:cNvSpPr/>
+          <p:nvPr/>
+        </p:nvSpPr>
+        <p:spPr>
+          <a:xfrm>
+            <a:off x="640080" y="2743200"/>
             <a:ext cx="1371600" cy="365760"/>
           </a:xfrm>
           <a:prstGeom prst="rect">
@@ -22628,13 +22889,13 @@
       </p:sp>
       <p:sp>
         <p:nvSpPr>
-          <p:cNvPr id="24" name="Text 22"/>
-          <p:cNvSpPr/>
-          <p:nvPr/>
-        </p:nvSpPr>
-        <p:spPr>
-          <a:xfrm>
-            <a:off x="685800" y="2011680"/>
+          <p:cNvPr id="40" name="Text 38"/>
+          <p:cNvSpPr/>
+          <p:nvPr/>
+        </p:nvSpPr>
+        <p:spPr>
+          <a:xfrm>
+            <a:off x="685800" y="2743200"/>
             <a:ext cx="1280160" cy="365760"/>
           </a:xfrm>
           <a:prstGeom prst="rect">
@@ -22667,13 +22928,13 @@
       </p:sp>
       <p:sp>
         <p:nvSpPr>
-          <p:cNvPr id="25" name="Shape 23"/>
-          <p:cNvSpPr/>
-          <p:nvPr/>
-        </p:nvSpPr>
-        <p:spPr>
-          <a:xfrm>
-            <a:off x="2011680" y="2011680"/>
+          <p:cNvPr id="41" name="Shape 39"/>
+          <p:cNvSpPr/>
+          <p:nvPr/>
+        </p:nvSpPr>
+        <p:spPr>
+          <a:xfrm>
+            <a:off x="2011680" y="2743200"/>
             <a:ext cx="1371600" cy="365760"/>
           </a:xfrm>
           <a:prstGeom prst="rect">
@@ -22692,13 +22953,13 @@
       </p:sp>
       <p:sp>
         <p:nvSpPr>
-          <p:cNvPr id="26" name="Text 24"/>
-          <p:cNvSpPr/>
-          <p:nvPr/>
-        </p:nvSpPr>
-        <p:spPr>
-          <a:xfrm>
-            <a:off x="2057400" y="2011680"/>
+          <p:cNvPr id="42" name="Text 40"/>
+          <p:cNvSpPr/>
+          <p:nvPr/>
+        </p:nvSpPr>
+        <p:spPr>
+          <a:xfrm>
+            <a:off x="2057400" y="2743200"/>
             <a:ext cx="1280160" cy="365760"/>
           </a:xfrm>
           <a:prstGeom prst="rect">
@@ -22723,7 +22984,7 @@
                 <a:ea typeface="Arial" pitchFamily="34" charset="-122"/>
                 <a:cs typeface="Arial" pitchFamily="34" charset="-120"/>
               </a:rPr>
-              <a:t>continuous</a:t>
+              <a:t>categorical</a:t>
             </a:r>
             <a:endParaRPr lang="en-US" sz="1100" dirty="0"/>
           </a:p>
@@ -22731,13 +22992,13 @@
       </p:sp>
       <p:sp>
         <p:nvSpPr>
-          <p:cNvPr id="27" name="Shape 25"/>
-          <p:cNvSpPr/>
-          <p:nvPr/>
-        </p:nvSpPr>
-        <p:spPr>
-          <a:xfrm>
-            <a:off x="3383280" y="2011680"/>
+          <p:cNvPr id="43" name="Shape 41"/>
+          <p:cNvSpPr/>
+          <p:nvPr/>
+        </p:nvSpPr>
+        <p:spPr>
+          <a:xfrm>
+            <a:off x="3383280" y="2743200"/>
             <a:ext cx="2377440" cy="365760"/>
           </a:xfrm>
           <a:prstGeom prst="rect">
@@ -22756,518 +23017,6 @@
       </p:sp>
       <p:sp>
         <p:nvSpPr>
-          <p:cNvPr id="28" name="Text 26"/>
-          <p:cNvSpPr/>
-          <p:nvPr/>
-        </p:nvSpPr>
-        <p:spPr>
-          <a:xfrm>
-            <a:off x="3429000" y="2011680"/>
-            <a:ext cx="2286000" cy="365760"/>
-          </a:xfrm>
-          <a:prstGeom prst="rect">
-            <a:avLst/>
-          </a:prstGeom>
-          <a:noFill/>
-          <a:ln/>
-        </p:spPr>
-        <p:txBody>
-          <a:bodyPr wrap="square" lIns="0" tIns="0" rIns="0" bIns="0" rtlCol="0" anchor="ctr"/>
-          <a:lstStyle/>
-          <a:p>
-            <a:pPr indent="0" marL="0">
-              <a:buNone/>
-            </a:pPr>
-            <a:r>
-              <a:rPr lang="en-US" sz="1100" dirty="0">
-                <a:solidFill>
-                  <a:srgbClr val="374151"/>
-                </a:solidFill>
-                <a:latin typeface="Arial" pitchFamily="34" charset="0"/>
-                <a:ea typeface="Arial" pitchFamily="34" charset="-122"/>
-                <a:cs typeface="Arial" pitchFamily="34" charset="-120"/>
-              </a:rPr>
-              <a:t>One-way ANOVA</a:t>
-            </a:r>
-            <a:endParaRPr lang="en-US" sz="1100" dirty="0"/>
-          </a:p>
-        </p:txBody>
-      </p:sp>
-      <p:sp>
-        <p:nvSpPr>
-          <p:cNvPr id="29" name="Shape 27"/>
-          <p:cNvSpPr/>
-          <p:nvPr/>
-        </p:nvSpPr>
-        <p:spPr>
-          <a:xfrm>
-            <a:off x="5760720" y="2011680"/>
-            <a:ext cx="2286000" cy="365760"/>
-          </a:xfrm>
-          <a:prstGeom prst="rect">
-            <a:avLst/>
-          </a:prstGeom>
-          <a:solidFill>
-            <a:srgbClr val="F3F4F6"/>
-          </a:solidFill>
-          <a:ln w="6350">
-            <a:solidFill>
-              <a:srgbClr val="D1D5DB"/>
-            </a:solidFill>
-            <a:prstDash val="solid"/>
-          </a:ln>
-        </p:spPr>
-      </p:sp>
-      <p:sp>
-        <p:nvSpPr>
-          <p:cNvPr id="30" name="Text 28"/>
-          <p:cNvSpPr/>
-          <p:nvPr/>
-        </p:nvSpPr>
-        <p:spPr>
-          <a:xfrm>
-            <a:off x="5806440" y="2011680"/>
-            <a:ext cx="2194560" cy="365760"/>
-          </a:xfrm>
-          <a:prstGeom prst="rect">
-            <a:avLst/>
-          </a:prstGeom>
-          <a:noFill/>
-          <a:ln/>
-        </p:spPr>
-        <p:txBody>
-          <a:bodyPr wrap="square" lIns="0" tIns="0" rIns="0" bIns="0" rtlCol="0" anchor="ctr"/>
-          <a:lstStyle/>
-          <a:p>
-            <a:pPr indent="0" marL="0">
-              <a:buNone/>
-            </a:pPr>
-            <a:r>
-              <a:rPr lang="en-US" sz="1100" dirty="0">
-                <a:solidFill>
-                  <a:srgbClr val="374151"/>
-                </a:solidFill>
-                <a:latin typeface="Arial" pitchFamily="34" charset="0"/>
-                <a:ea typeface="Arial" pitchFamily="34" charset="-122"/>
-                <a:cs typeface="Arial" pitchFamily="34" charset="-120"/>
-              </a:rPr>
-              <a:t>η² (eta-squared)</a:t>
-            </a:r>
-            <a:endParaRPr lang="en-US" sz="1100" dirty="0"/>
-          </a:p>
-        </p:txBody>
-      </p:sp>
-      <p:sp>
-        <p:nvSpPr>
-          <p:cNvPr id="31" name="Shape 29"/>
-          <p:cNvSpPr/>
-          <p:nvPr/>
-        </p:nvSpPr>
-        <p:spPr>
-          <a:xfrm>
-            <a:off x="640080" y="2377440"/>
-            <a:ext cx="1371600" cy="365760"/>
-          </a:xfrm>
-          <a:prstGeom prst="rect">
-            <a:avLst/>
-          </a:prstGeom>
-          <a:solidFill>
-            <a:srgbClr val="FFFFFF"/>
-          </a:solidFill>
-          <a:ln w="6350">
-            <a:solidFill>
-              <a:srgbClr val="D1D5DB"/>
-            </a:solidFill>
-            <a:prstDash val="solid"/>
-          </a:ln>
-        </p:spPr>
-      </p:sp>
-      <p:sp>
-        <p:nvSpPr>
-          <p:cNvPr id="32" name="Text 30"/>
-          <p:cNvSpPr/>
-          <p:nvPr/>
-        </p:nvSpPr>
-        <p:spPr>
-          <a:xfrm>
-            <a:off x="685800" y="2377440"/>
-            <a:ext cx="1280160" cy="365760"/>
-          </a:xfrm>
-          <a:prstGeom prst="rect">
-            <a:avLst/>
-          </a:prstGeom>
-          <a:noFill/>
-          <a:ln/>
-        </p:spPr>
-        <p:txBody>
-          <a:bodyPr wrap="square" lIns="0" tIns="0" rIns="0" bIns="0" rtlCol="0" anchor="ctr"/>
-          <a:lstStyle/>
-          <a:p>
-            <a:pPr indent="0" marL="0">
-              <a:buNone/>
-            </a:pPr>
-            <a:r>
-              <a:rPr lang="en-US" sz="1100" dirty="0">
-                <a:solidFill>
-                  <a:srgbClr val="374151"/>
-                </a:solidFill>
-                <a:latin typeface="Arial" pitchFamily="34" charset="0"/>
-                <a:ea typeface="Arial" pitchFamily="34" charset="-122"/>
-                <a:cs typeface="Arial" pitchFamily="34" charset="-120"/>
-              </a:rPr>
-              <a:t>continuous</a:t>
-            </a:r>
-            <a:endParaRPr lang="en-US" sz="1100" dirty="0"/>
-          </a:p>
-        </p:txBody>
-      </p:sp>
-      <p:sp>
-        <p:nvSpPr>
-          <p:cNvPr id="33" name="Shape 31"/>
-          <p:cNvSpPr/>
-          <p:nvPr/>
-        </p:nvSpPr>
-        <p:spPr>
-          <a:xfrm>
-            <a:off x="2011680" y="2377440"/>
-            <a:ext cx="1371600" cy="365760"/>
-          </a:xfrm>
-          <a:prstGeom prst="rect">
-            <a:avLst/>
-          </a:prstGeom>
-          <a:solidFill>
-            <a:srgbClr val="FFFFFF"/>
-          </a:solidFill>
-          <a:ln w="6350">
-            <a:solidFill>
-              <a:srgbClr val="D1D5DB"/>
-            </a:solidFill>
-            <a:prstDash val="solid"/>
-          </a:ln>
-        </p:spPr>
-      </p:sp>
-      <p:sp>
-        <p:nvSpPr>
-          <p:cNvPr id="34" name="Text 32"/>
-          <p:cNvSpPr/>
-          <p:nvPr/>
-        </p:nvSpPr>
-        <p:spPr>
-          <a:xfrm>
-            <a:off x="2057400" y="2377440"/>
-            <a:ext cx="1280160" cy="365760"/>
-          </a:xfrm>
-          <a:prstGeom prst="rect">
-            <a:avLst/>
-          </a:prstGeom>
-          <a:noFill/>
-          <a:ln/>
-        </p:spPr>
-        <p:txBody>
-          <a:bodyPr wrap="square" lIns="0" tIns="0" rIns="0" bIns="0" rtlCol="0" anchor="ctr"/>
-          <a:lstStyle/>
-          <a:p>
-            <a:pPr indent="0" marL="0">
-              <a:buNone/>
-            </a:pPr>
-            <a:r>
-              <a:rPr lang="en-US" sz="1100" dirty="0">
-                <a:solidFill>
-                  <a:srgbClr val="374151"/>
-                </a:solidFill>
-                <a:latin typeface="Arial" pitchFamily="34" charset="0"/>
-                <a:ea typeface="Arial" pitchFamily="34" charset="-122"/>
-                <a:cs typeface="Arial" pitchFamily="34" charset="-120"/>
-              </a:rPr>
-              <a:t>continuous</a:t>
-            </a:r>
-            <a:endParaRPr lang="en-US" sz="1100" dirty="0"/>
-          </a:p>
-        </p:txBody>
-      </p:sp>
-      <p:sp>
-        <p:nvSpPr>
-          <p:cNvPr id="35" name="Shape 33"/>
-          <p:cNvSpPr/>
-          <p:nvPr/>
-        </p:nvSpPr>
-        <p:spPr>
-          <a:xfrm>
-            <a:off x="3383280" y="2377440"/>
-            <a:ext cx="2377440" cy="365760"/>
-          </a:xfrm>
-          <a:prstGeom prst="rect">
-            <a:avLst/>
-          </a:prstGeom>
-          <a:solidFill>
-            <a:srgbClr val="FFFFFF"/>
-          </a:solidFill>
-          <a:ln w="6350">
-            <a:solidFill>
-              <a:srgbClr val="D1D5DB"/>
-            </a:solidFill>
-            <a:prstDash val="solid"/>
-          </a:ln>
-        </p:spPr>
-      </p:sp>
-      <p:sp>
-        <p:nvSpPr>
-          <p:cNvPr id="36" name="Text 34"/>
-          <p:cNvSpPr/>
-          <p:nvPr/>
-        </p:nvSpPr>
-        <p:spPr>
-          <a:xfrm>
-            <a:off x="3429000" y="2377440"/>
-            <a:ext cx="2286000" cy="365760"/>
-          </a:xfrm>
-          <a:prstGeom prst="rect">
-            <a:avLst/>
-          </a:prstGeom>
-          <a:noFill/>
-          <a:ln/>
-        </p:spPr>
-        <p:txBody>
-          <a:bodyPr wrap="square" lIns="0" tIns="0" rIns="0" bIns="0" rtlCol="0" anchor="ctr"/>
-          <a:lstStyle/>
-          <a:p>
-            <a:pPr indent="0" marL="0">
-              <a:buNone/>
-            </a:pPr>
-            <a:r>
-              <a:rPr lang="en-US" sz="1100" dirty="0">
-                <a:solidFill>
-                  <a:srgbClr val="374151"/>
-                </a:solidFill>
-                <a:latin typeface="Arial" pitchFamily="34" charset="0"/>
-                <a:ea typeface="Arial" pitchFamily="34" charset="-122"/>
-                <a:cs typeface="Arial" pitchFamily="34" charset="-120"/>
-              </a:rPr>
-              <a:t>Pearson correlation</a:t>
-            </a:r>
-            <a:endParaRPr lang="en-US" sz="1100" dirty="0"/>
-          </a:p>
-        </p:txBody>
-      </p:sp>
-      <p:sp>
-        <p:nvSpPr>
-          <p:cNvPr id="37" name="Shape 35"/>
-          <p:cNvSpPr/>
-          <p:nvPr/>
-        </p:nvSpPr>
-        <p:spPr>
-          <a:xfrm>
-            <a:off x="5760720" y="2377440"/>
-            <a:ext cx="2286000" cy="365760"/>
-          </a:xfrm>
-          <a:prstGeom prst="rect">
-            <a:avLst/>
-          </a:prstGeom>
-          <a:solidFill>
-            <a:srgbClr val="FFFFFF"/>
-          </a:solidFill>
-          <a:ln w="6350">
-            <a:solidFill>
-              <a:srgbClr val="D1D5DB"/>
-            </a:solidFill>
-            <a:prstDash val="solid"/>
-          </a:ln>
-        </p:spPr>
-      </p:sp>
-      <p:sp>
-        <p:nvSpPr>
-          <p:cNvPr id="38" name="Text 36"/>
-          <p:cNvSpPr/>
-          <p:nvPr/>
-        </p:nvSpPr>
-        <p:spPr>
-          <a:xfrm>
-            <a:off x="5806440" y="2377440"/>
-            <a:ext cx="2194560" cy="365760"/>
-          </a:xfrm>
-          <a:prstGeom prst="rect">
-            <a:avLst/>
-          </a:prstGeom>
-          <a:noFill/>
-          <a:ln/>
-        </p:spPr>
-        <p:txBody>
-          <a:bodyPr wrap="square" lIns="0" tIns="0" rIns="0" bIns="0" rtlCol="0" anchor="ctr"/>
-          <a:lstStyle/>
-          <a:p>
-            <a:pPr indent="0" marL="0">
-              <a:buNone/>
-            </a:pPr>
-            <a:r>
-              <a:rPr lang="en-US" sz="1100" dirty="0">
-                <a:solidFill>
-                  <a:srgbClr val="374151"/>
-                </a:solidFill>
-                <a:latin typeface="Arial" pitchFamily="34" charset="0"/>
-                <a:ea typeface="Arial" pitchFamily="34" charset="-122"/>
-                <a:cs typeface="Arial" pitchFamily="34" charset="-120"/>
-              </a:rPr>
-              <a:t>r</a:t>
-            </a:r>
-            <a:endParaRPr lang="en-US" sz="1100" dirty="0"/>
-          </a:p>
-        </p:txBody>
-      </p:sp>
-      <p:sp>
-        <p:nvSpPr>
-          <p:cNvPr id="39" name="Shape 37"/>
-          <p:cNvSpPr/>
-          <p:nvPr/>
-        </p:nvSpPr>
-        <p:spPr>
-          <a:xfrm>
-            <a:off x="640080" y="2743200"/>
-            <a:ext cx="1371600" cy="365760"/>
-          </a:xfrm>
-          <a:prstGeom prst="rect">
-            <a:avLst/>
-          </a:prstGeom>
-          <a:solidFill>
-            <a:srgbClr val="F3F4F6"/>
-          </a:solidFill>
-          <a:ln w="6350">
-            <a:solidFill>
-              <a:srgbClr val="D1D5DB"/>
-            </a:solidFill>
-            <a:prstDash val="solid"/>
-          </a:ln>
-        </p:spPr>
-      </p:sp>
-      <p:sp>
-        <p:nvSpPr>
-          <p:cNvPr id="40" name="Text 38"/>
-          <p:cNvSpPr/>
-          <p:nvPr/>
-        </p:nvSpPr>
-        <p:spPr>
-          <a:xfrm>
-            <a:off x="685800" y="2743200"/>
-            <a:ext cx="1280160" cy="365760"/>
-          </a:xfrm>
-          <a:prstGeom prst="rect">
-            <a:avLst/>
-          </a:prstGeom>
-          <a:noFill/>
-          <a:ln/>
-        </p:spPr>
-        <p:txBody>
-          <a:bodyPr wrap="square" lIns="0" tIns="0" rIns="0" bIns="0" rtlCol="0" anchor="ctr"/>
-          <a:lstStyle/>
-          <a:p>
-            <a:pPr indent="0" marL="0">
-              <a:buNone/>
-            </a:pPr>
-            <a:r>
-              <a:rPr lang="en-US" sz="1100" dirty="0">
-                <a:solidFill>
-                  <a:srgbClr val="374151"/>
-                </a:solidFill>
-                <a:latin typeface="Arial" pitchFamily="34" charset="0"/>
-                <a:ea typeface="Arial" pitchFamily="34" charset="-122"/>
-                <a:cs typeface="Arial" pitchFamily="34" charset="-120"/>
-              </a:rPr>
-              <a:t>categorical</a:t>
-            </a:r>
-            <a:endParaRPr lang="en-US" sz="1100" dirty="0"/>
-          </a:p>
-        </p:txBody>
-      </p:sp>
-      <p:sp>
-        <p:nvSpPr>
-          <p:cNvPr id="41" name="Shape 39"/>
-          <p:cNvSpPr/>
-          <p:nvPr/>
-        </p:nvSpPr>
-        <p:spPr>
-          <a:xfrm>
-            <a:off x="2011680" y="2743200"/>
-            <a:ext cx="1371600" cy="365760"/>
-          </a:xfrm>
-          <a:prstGeom prst="rect">
-            <a:avLst/>
-          </a:prstGeom>
-          <a:solidFill>
-            <a:srgbClr val="F3F4F6"/>
-          </a:solidFill>
-          <a:ln w="6350">
-            <a:solidFill>
-              <a:srgbClr val="D1D5DB"/>
-            </a:solidFill>
-            <a:prstDash val="solid"/>
-          </a:ln>
-        </p:spPr>
-      </p:sp>
-      <p:sp>
-        <p:nvSpPr>
-          <p:cNvPr id="42" name="Text 40"/>
-          <p:cNvSpPr/>
-          <p:nvPr/>
-        </p:nvSpPr>
-        <p:spPr>
-          <a:xfrm>
-            <a:off x="2057400" y="2743200"/>
-            <a:ext cx="1280160" cy="365760"/>
-          </a:xfrm>
-          <a:prstGeom prst="rect">
-            <a:avLst/>
-          </a:prstGeom>
-          <a:noFill/>
-          <a:ln/>
-        </p:spPr>
-        <p:txBody>
-          <a:bodyPr wrap="square" lIns="0" tIns="0" rIns="0" bIns="0" rtlCol="0" anchor="ctr"/>
-          <a:lstStyle/>
-          <a:p>
-            <a:pPr indent="0" marL="0">
-              <a:buNone/>
-            </a:pPr>
-            <a:r>
-              <a:rPr lang="en-US" sz="1100" dirty="0">
-                <a:solidFill>
-                  <a:srgbClr val="374151"/>
-                </a:solidFill>
-                <a:latin typeface="Arial" pitchFamily="34" charset="0"/>
-                <a:ea typeface="Arial" pitchFamily="34" charset="-122"/>
-                <a:cs typeface="Arial" pitchFamily="34" charset="-120"/>
-              </a:rPr>
-              <a:t>categorical</a:t>
-            </a:r>
-            <a:endParaRPr lang="en-US" sz="1100" dirty="0"/>
-          </a:p>
-        </p:txBody>
-      </p:sp>
-      <p:sp>
-        <p:nvSpPr>
-          <p:cNvPr id="43" name="Shape 41"/>
-          <p:cNvSpPr/>
-          <p:nvPr/>
-        </p:nvSpPr>
-        <p:spPr>
-          <a:xfrm>
-            <a:off x="3383280" y="2743200"/>
-            <a:ext cx="2377440" cy="365760"/>
-          </a:xfrm>
-          <a:prstGeom prst="rect">
-            <a:avLst/>
-          </a:prstGeom>
-          <a:solidFill>
-            <a:srgbClr val="F3F4F6"/>
-          </a:solidFill>
-          <a:ln w="6350">
-            <a:solidFill>
-              <a:srgbClr val="D1D5DB"/>
-            </a:solidFill>
-            <a:prstDash val="solid"/>
-          </a:ln>
-        </p:spPr>
-      </p:sp>
-      <p:sp>
-        <p:nvSpPr>
           <p:cNvPr id="44" name="Text 42"/>
           <p:cNvSpPr/>
           <p:nvPr/>
@@ -23300,70 +23049,6 @@
                 <a:cs typeface="Arial" pitchFamily="34" charset="-120"/>
               </a:rPr>
               <a:t>Chi-square</a:t>
-            </a:r>
-            <a:endParaRPr lang="en-US" sz="1100" dirty="0"/>
-          </a:p>
-        </p:txBody>
-      </p:sp>
-      <p:sp>
-        <p:nvSpPr>
-          <p:cNvPr id="45" name="Shape 43"/>
-          <p:cNvSpPr/>
-          <p:nvPr/>
-        </p:nvSpPr>
-        <p:spPr>
-          <a:xfrm>
-            <a:off x="5760720" y="2743200"/>
-            <a:ext cx="2286000" cy="365760"/>
-          </a:xfrm>
-          <a:prstGeom prst="rect">
-            <a:avLst/>
-          </a:prstGeom>
-          <a:solidFill>
-            <a:srgbClr val="F3F4F6"/>
-          </a:solidFill>
-          <a:ln w="6350">
-            <a:solidFill>
-              <a:srgbClr val="D1D5DB"/>
-            </a:solidFill>
-            <a:prstDash val="solid"/>
-          </a:ln>
-        </p:spPr>
-      </p:sp>
-      <p:sp>
-        <p:nvSpPr>
-          <p:cNvPr id="46" name="Text 44"/>
-          <p:cNvSpPr/>
-          <p:nvPr/>
-        </p:nvSpPr>
-        <p:spPr>
-          <a:xfrm>
-            <a:off x="5806440" y="2743200"/>
-            <a:ext cx="2194560" cy="365760"/>
-          </a:xfrm>
-          <a:prstGeom prst="rect">
-            <a:avLst/>
-          </a:prstGeom>
-          <a:noFill/>
-          <a:ln/>
-        </p:spPr>
-        <p:txBody>
-          <a:bodyPr wrap="square" lIns="0" tIns="0" rIns="0" bIns="0" rtlCol="0" anchor="ctr"/>
-          <a:lstStyle/>
-          <a:p>
-            <a:pPr indent="0" marL="0">
-              <a:buNone/>
-            </a:pPr>
-            <a:r>
-              <a:rPr lang="en-US" sz="1100" dirty="0">
-                <a:solidFill>
-                  <a:srgbClr val="374151"/>
-                </a:solidFill>
-                <a:latin typeface="Arial" pitchFamily="34" charset="0"/>
-                <a:ea typeface="Arial" pitchFamily="34" charset="-122"/>
-                <a:cs typeface="Arial" pitchFamily="34" charset="-120"/>
-              </a:rPr>
-              <a:t>Cramer's V</a:t>
             </a:r>
             <a:endParaRPr lang="en-US" sz="1100" dirty="0"/>
           </a:p>

</xml_diff>

<commit_message>
Module 1: drop FDR — use plain p < 0.05 (notebook + slides 6, 8, 29)
</commit_message>
<xml_diff>
--- a/Integrated Data Analytics Exercise/slides/MADT6004_Wrap_Up_Session.pptx
+++ b/Integrated Data Analytics Exercise/slides/MADT6004_Wrap_Up_Session.pptx
@@ -17697,7 +17697,7 @@
                 <a:ea typeface="Arial" pitchFamily="34" charset="-122"/>
                 <a:cs typeface="Arial" pitchFamily="34" charset="-120"/>
               </a:rPr>
-              <a:t>Eight habits worth taking with you</a:t>
+              <a:t>Seven habits worth taking with you</a:t>
             </a:r>
             <a:endParaRPr lang="en-US" sz="2800" dirty="0"/>
           </a:p>
@@ -17822,45 +17822,6 @@
       </p:sp>
       <p:sp>
         <p:nvSpPr>
-          <p:cNvPr id="9" name="Text 7"/>
-          <p:cNvSpPr/>
-          <p:nvPr/>
-        </p:nvSpPr>
-        <p:spPr>
-          <a:xfrm>
-            <a:off x="640080" y="2048256"/>
-            <a:ext cx="7863840" cy="365760"/>
-          </a:xfrm>
-          <a:prstGeom prst="rect">
-            <a:avLst/>
-          </a:prstGeom>
-          <a:noFill/>
-          <a:ln/>
-        </p:spPr>
-        <p:txBody>
-          <a:bodyPr wrap="square" lIns="0" tIns="0" rIns="0" bIns="0" rtlCol="0" anchor="ctr"/>
-          <a:lstStyle/>
-          <a:p>
-            <a:pPr indent="0" marL="0">
-              <a:buNone/>
-            </a:pPr>
-            <a:r>
-              <a:rPr lang="en-US" sz="1300" dirty="0">
-                <a:solidFill>
-                  <a:srgbClr val="374151"/>
-                </a:solidFill>
-                <a:latin typeface="Arial" pitchFamily="34" charset="0"/>
-                <a:ea typeface="Arial" pitchFamily="34" charset="-122"/>
-                <a:cs typeface="Arial" pitchFamily="34" charset="-120"/>
-              </a:rPr>
-              <a:t>3. FDR-correct when you sweep. Always.</a:t>
-            </a:r>
-            <a:endParaRPr lang="en-US" sz="1300" dirty="0"/>
-          </a:p>
-        </p:txBody>
-      </p:sp>
-      <p:sp>
-        <p:nvSpPr>
           <p:cNvPr id="10" name="Text 8"/>
           <p:cNvSpPr/>
           <p:nvPr/>
@@ -17892,7 +17853,7 @@
                 <a:ea typeface="Arial" pitchFamily="34" charset="-122"/>
                 <a:cs typeface="Arial" pitchFamily="34" charset="-120"/>
               </a:rPr>
-              <a:t>4. Confirm with regression + interactions when the simple test surprises you.</a:t>
+              <a:t>3. Confirm with regression + interactions when the simple test surprises you.</a:t>
             </a:r>
             <a:endParaRPr lang="en-US" sz="1300" dirty="0"/>
           </a:p>
@@ -17931,7 +17892,7 @@
                 <a:ea typeface="Arial" pitchFamily="34" charset="-122"/>
                 <a:cs typeface="Arial" pitchFamily="34" charset="-120"/>
               </a:rPr>
-              <a:t>5. Try the simple forecasts first. They often win.</a:t>
+              <a:t>4. Try the simple forecasts first. They often win.</a:t>
             </a:r>
             <a:endParaRPr lang="en-US" sz="1300" dirty="0"/>
           </a:p>
@@ -17970,7 +17931,7 @@
                 <a:ea typeface="Arial" pitchFamily="34" charset="-122"/>
                 <a:cs typeface="Arial" pitchFamily="34" charset="-120"/>
               </a:rPr>
-              <a:t>6. Measure model fit with the metric the business actually cares about.</a:t>
+              <a:t>5. Measure model fit with the metric the business actually cares about.</a:t>
             </a:r>
             <a:endParaRPr lang="en-US" sz="1300" dirty="0"/>
           </a:p>
@@ -18009,7 +17970,7 @@
                 <a:ea typeface="Arial" pitchFamily="34" charset="-122"/>
                 <a:cs typeface="Arial" pitchFamily="34" charset="-120"/>
               </a:rPr>
-              <a:t>7. Imbalanced classes need stratified splits and lift charts. Accuracy is misleading.</a:t>
+              <a:t>6. Imbalanced classes need stratified splits and lift charts. Accuracy is misleading.</a:t>
             </a:r>
             <a:endParaRPr lang="en-US" sz="1300" dirty="0"/>
           </a:p>
@@ -18048,7 +18009,7 @@
                 <a:ea typeface="Arial" pitchFamily="34" charset="-122"/>
                 <a:cs typeface="Arial" pitchFamily="34" charset="-120"/>
               </a:rPr>
-              <a:t>8. Read the reviews. Sentiment is a leading indicator for the dashboards.</a:t>
+              <a:t>7. Read the reviews. Sentiment is a leading indicator for the dashboards.</a:t>
             </a:r>
             <a:endParaRPr lang="en-US" sz="1300" dirty="0"/>
           </a:p>
@@ -21214,7 +21175,7 @@
                 <a:ea typeface="Arial" pitchFamily="34" charset="-122"/>
                 <a:cs typeface="Arial" pitchFamily="34" charset="-120"/>
               </a:rPr>
-              <a:t>•  Apply FDR (Benjamini-Hochberg) correction
+              <a:t>•  Filter to p &lt; 0.05 — and report the full table, not just the wins
 </a:t>
             </a:r>
             <a:pPr indent="0" marL="0">
@@ -23140,7 +23101,7 @@
                 <a:ea typeface="Arial" pitchFamily="34" charset="-122"/>
                 <a:cs typeface="Arial" pitchFamily="34" charset="-120"/>
               </a:rPr>
-              <a:t>Apply Benjamini-Hochberg FDR correction across all p-values
+              <a:t>Filter to p &lt; 0.05 — those are your candidate findings
 </a:t>
             </a:r>
             <a:pPr indent="0" marL="0">
@@ -23156,35 +23117,6 @@
                 <a:cs typeface="Arial" pitchFamily="34" charset="-120"/>
               </a:rPr>
               <a:t>2.  </a:t>
-            </a:r>
-            <a:pPr indent="0" marL="0">
-              <a:buNone/>
-            </a:pPr>
-            <a:r>
-              <a:rPr lang="en-US" sz="1200" dirty="0">
-                <a:solidFill>
-                  <a:srgbClr val="374151"/>
-                </a:solidFill>
-                <a:latin typeface="Arial" pitchFamily="34" charset="0"/>
-                <a:ea typeface="Arial" pitchFamily="34" charset="-122"/>
-                <a:cs typeface="Arial" pitchFamily="34" charset="-120"/>
-              </a:rPr>
-              <a:t>Filter to q &lt; 0.05 — those are your real findings
-</a:t>
-            </a:r>
-            <a:pPr indent="0" marL="0">
-              <a:buNone/>
-            </a:pPr>
-            <a:r>
-              <a:rPr lang="en-US" sz="1200" b="1" dirty="0">
-                <a:solidFill>
-                  <a:srgbClr val="0891B2"/>
-                </a:solidFill>
-                <a:latin typeface="Arial" pitchFamily="34" charset="0"/>
-                <a:ea typeface="Arial" pitchFamily="34" charset="-122"/>
-                <a:cs typeface="Arial" pitchFamily="34" charset="-120"/>
-              </a:rPr>
-              <a:t>3.  </a:t>
             </a:r>
             <a:pPr indent="0" marL="0">
               <a:buNone/>

</xml_diff>

<commit_message>
Slides: add operating-model + data-tables background slides after slide 2
</commit_message>
<xml_diff>
--- a/Integrated Data Analytics Exercise/slides/MADT6004_Wrap_Up_Session.pptx
+++ b/Integrated Data Analytics Exercise/slides/MADT6004_Wrap_Up_Session.pptx
@@ -7,6 +7,8 @@
   <p:sldIdLst>
     <p:sldId id="256" r:id="rId2"/>
     <p:sldId id="257" r:id="rId3"/>
+    <p:sldId id="286" r:id="rId37"/>
+    <p:sldId id="287" r:id="rId38"/>
     <p:sldId id="258" r:id="rId4"/>
     <p:sldId id="259" r:id="rId5"/>
     <p:sldId id="260" r:id="rId6"/>
@@ -19272,6 +19274,2197 @@
 </p:sld>
 </file>
 
+<file path=ppt/slides/slide31.xml><?xml version="1.0" encoding="utf-8"?>
+<p:sld xmlns:a="http://schemas.openxmlformats.org/drawingml/2006/main" xmlns:r="http://schemas.openxmlformats.org/officeDocument/2006/relationships" xmlns:p="http://schemas.openxmlformats.org/presentationml/2006/main">
+  <p:cSld name="Slide 31 — operating model">
+    <p:bg>
+      <p:bgPr>
+        <a:solidFill>
+          <a:srgbClr val="FFFFFF"/>
+        </a:solidFill>
+      </p:bgPr>
+    </p:bg>
+    <p:spTree>
+      <p:nvGrpSpPr>
+        <p:cNvPr id="1" name=""/>
+        <p:cNvGrpSpPr/>
+        <p:nvPr/>
+      </p:nvGrpSpPr>
+      <p:grpSpPr>
+        <a:xfrm>
+          <a:off x="0" y="0"/>
+          <a:ext cx="0" cy="0"/>
+          <a:chOff x="0" y="0"/>
+          <a:chExt cx="0" cy="0"/>
+        </a:xfrm>
+      </p:grpSpPr>
+      <p:sp>
+        <p:nvSpPr>
+          <p:cNvPr id="2" name="Shape 0"/>
+          <p:cNvSpPr/>
+          <p:nvPr/>
+        </p:nvSpPr>
+        <p:spPr>
+          <a:xfrm>
+            <a:off x="0" y="0"/>
+            <a:ext cx="9144000" cy="45720"/>
+          </a:xfrm>
+          <a:prstGeom prst="rect">
+            <a:avLst/>
+          </a:prstGeom>
+          <a:solidFill>
+            <a:srgbClr val="0891B2"/>
+          </a:solidFill>
+          <a:ln/>
+        </p:spPr>
+      </p:sp>
+      <p:sp>
+        <p:nvSpPr>
+          <p:cNvPr id="3" name="Footer"/>
+          <p:cNvSpPr/>
+          <p:nvPr/>
+        </p:nvSpPr>
+        <p:spPr>
+          <a:xfrm>
+            <a:off x="640080" y="4828032"/>
+            <a:ext cx="5486400" cy="228600"/>
+          </a:xfrm>
+          <a:prstGeom prst="rect">
+            <a:avLst/>
+          </a:prstGeom>
+          <a:noFill/>
+          <a:ln/>
+        </p:spPr>
+        <p:txBody>
+          <a:bodyPr wrap="square" lIns="0" tIns="0" rIns="0" bIns="0" rtlCol="0" anchor="ctr"/>
+          <a:lstStyle/>
+          <a:p>
+            <a:pPr indent="0" marL="0">
+              <a:buNone/>
+            </a:pPr>
+            <a:r>
+              <a:rPr lang="en-US" sz="900" dirty="0">
+                <a:solidFill>
+                  <a:srgbClr val="9CA3AF"/>
+                </a:solidFill>
+                <a:latin typeface="Arial" pitchFamily="34" charset="0"/>
+                <a:ea typeface="Arial" pitchFamily="34" charset="-122"/>
+                <a:cs typeface="Arial" pitchFamily="34" charset="-120"/>
+              </a:rPr>
+              <a:t>NIDA  |  MADT6004  |  Setup</a:t>
+            </a:r>
+            <a:endParaRPr lang="en-US" sz="900" dirty="0"/>
+          </a:p>
+        </p:txBody>
+      </p:sp>
+      <p:sp>
+        <p:nvSpPr>
+          <p:cNvPr id="4" name="Badge"/>
+          <p:cNvSpPr/>
+          <p:nvPr/>
+        </p:nvSpPr>
+        <p:spPr>
+          <a:xfrm>
+            <a:off x="7772400" y="4800600"/>
+            <a:ext cx="914400" cy="274320"/>
+          </a:xfrm>
+          <a:prstGeom prst="rect">
+            <a:avLst/>
+          </a:prstGeom>
+          <a:noFill/>
+          <a:ln/>
+        </p:spPr>
+        <p:txBody>
+          <a:bodyPr wrap="square" lIns="0" tIns="0" rIns="0" bIns="0" rtlCol="0" anchor="ctr"/>
+          <a:lstStyle/>
+          <a:p>
+            <a:pPr algn="r" indent="0" marL="0">
+              <a:buNone/>
+            </a:pPr>
+            <a:r>
+              <a:rPr lang="en-US" sz="1200" b="1" dirty="0">
+                <a:solidFill>
+                  <a:srgbClr val="0891B2"/>
+                </a:solidFill>
+                <a:latin typeface="Arial" pitchFamily="34" charset="0"/>
+                <a:ea typeface="Arial" pitchFamily="34" charset="-122"/>
+                <a:cs typeface="Arial" pitchFamily="34" charset="-120"/>
+              </a:rPr>
+              <a:t>MADT</a:t>
+            </a:r>
+            <a:endParaRPr lang="en-US" sz="1200" dirty="0"/>
+          </a:p>
+        </p:txBody>
+      </p:sp>
+      <p:sp>
+        <p:nvSpPr>
+          <p:cNvPr id="5" name="Title"/>
+          <p:cNvSpPr/>
+          <p:nvPr/>
+        </p:nvSpPr>
+        <p:spPr>
+          <a:xfrm>
+            <a:off x="640080" y="274320"/>
+            <a:ext cx="7863840" cy="502920"/>
+          </a:xfrm>
+          <a:prstGeom prst="rect">
+            <a:avLst/>
+          </a:prstGeom>
+          <a:noFill/>
+          <a:ln/>
+        </p:spPr>
+        <p:txBody>
+          <a:bodyPr wrap="square" lIns="0" tIns="0" rIns="0" bIns="0" rtlCol="0" anchor="ctr"/>
+          <a:lstStyle/>
+          <a:p>
+            <a:pPr indent="0" marL="0">
+              <a:buNone/>
+            </a:pPr>
+            <a:r>
+              <a:rPr lang="en-US" sz="2800" b="1" dirty="0">
+                <a:solidFill>
+                  <a:srgbClr val="1F2937"/>
+                </a:solidFill>
+                <a:latin typeface="Arial" pitchFamily="34" charset="0"/>
+                <a:ea typeface="Arial" pitchFamily="34" charset="-122"/>
+                <a:cs typeface="Arial" pitchFamily="34" charset="-120"/>
+              </a:rPr>
+              <a:t>Brew Lab BKK — operating model</a:t>
+            </a:r>
+            <a:endParaRPr lang="en-US" sz="2800" dirty="0"/>
+          </a:p>
+        </p:txBody>
+      </p:sp>
+      <p:sp>
+        <p:nvSpPr>
+          <p:cNvPr id="6" name="Subtitle"/>
+          <p:cNvSpPr/>
+          <p:nvPr/>
+        </p:nvSpPr>
+        <p:spPr>
+          <a:xfrm>
+            <a:off x="640080" y="777240"/>
+            <a:ext cx="7863840" cy="274320"/>
+          </a:xfrm>
+          <a:prstGeom prst="rect">
+            <a:avLst/>
+          </a:prstGeom>
+          <a:noFill/>
+          <a:ln/>
+        </p:spPr>
+        <p:txBody>
+          <a:bodyPr wrap="square" lIns="0" tIns="0" rIns="0" bIns="0" rtlCol="0" anchor="ctr"/>
+          <a:lstStyle/>
+          <a:p>
+            <a:pPr indent="0" marL="0">
+              <a:buNone/>
+            </a:pPr>
+            <a:r>
+              <a:rPr lang="en-US" sz="1300" i="1" dirty="0">
+                <a:solidFill>
+                  <a:srgbClr val="6B7280"/>
+                </a:solidFill>
+                <a:latin typeface="Arial" pitchFamily="34" charset="0"/>
+                <a:ea typeface="Arial" pitchFamily="34" charset="-122"/>
+                <a:cs typeface="Arial" pitchFamily="34" charset="-120"/>
+              </a:rPr>
+              <a:t>How the business runs day-to-day</a:t>
+            </a:r>
+            <a:endParaRPr lang="en-US" sz="1300" dirty="0"/>
+          </a:p>
+        </p:txBody>
+      </p:sp>
+      <p:sp>
+        <p:nvSpPr>
+          <p:cNvPr id="7" name="Stat0"/>
+          <p:cNvSpPr/>
+          <p:nvPr/>
+        </p:nvSpPr>
+        <p:spPr>
+          <a:xfrm>
+            <a:off x="640080" y="1280160"/>
+            <a:ext cx="1463040" cy="640080"/>
+          </a:xfrm>
+          <a:prstGeom prst="rect">
+            <a:avLst/>
+          </a:prstGeom>
+          <a:noFill/>
+          <a:ln/>
+        </p:spPr>
+        <p:txBody>
+          <a:bodyPr wrap="square" lIns="0" tIns="0" rIns="0" bIns="0" rtlCol="0" anchor="ctr"/>
+          <a:lstStyle/>
+          <a:p>
+            <a:pPr algn="ctr" indent="0" marL="0">
+              <a:buNone/>
+            </a:pPr>
+            <a:r>
+              <a:rPr lang="en-US" sz="3600" b="1" dirty="0">
+                <a:solidFill>
+                  <a:srgbClr val="0891B2"/>
+                </a:solidFill>
+                <a:latin typeface="Arial" pitchFamily="34" charset="0"/>
+                <a:ea typeface="Arial" pitchFamily="34" charset="-122"/>
+                <a:cs typeface="Arial" pitchFamily="34" charset="-120"/>
+              </a:rPr>
+              <a:t>4</a:t>
+            </a:r>
+            <a:endParaRPr lang="en-US" sz="3600" dirty="0"/>
+          </a:p>
+        </p:txBody>
+      </p:sp>
+      <p:sp>
+        <p:nvSpPr>
+          <p:cNvPr id="8" name="StatLabel0"/>
+          <p:cNvSpPr/>
+          <p:nvPr/>
+        </p:nvSpPr>
+        <p:spPr>
+          <a:xfrm>
+            <a:off x="640080" y="1874520"/>
+            <a:ext cx="1463040" cy="274320"/>
+          </a:xfrm>
+          <a:prstGeom prst="rect">
+            <a:avLst/>
+          </a:prstGeom>
+          <a:noFill/>
+          <a:ln/>
+        </p:spPr>
+        <p:txBody>
+          <a:bodyPr wrap="square" lIns="0" tIns="0" rIns="0" bIns="0" rtlCol="0" anchor="ctr"/>
+          <a:lstStyle/>
+          <a:p>
+            <a:pPr algn="ctr" indent="0" marL="0">
+              <a:buNone/>
+            </a:pPr>
+            <a:r>
+              <a:rPr lang="en-US" sz="1100" dirty="0">
+                <a:solidFill>
+                  <a:srgbClr val="6B7280"/>
+                </a:solidFill>
+                <a:latin typeface="Arial" pitchFamily="34" charset="0"/>
+                <a:ea typeface="Arial" pitchFamily="34" charset="-122"/>
+                <a:cs typeface="Arial" pitchFamily="34" charset="-120"/>
+              </a:rPr>
+              <a:t>drive-thrus</a:t>
+            </a:r>
+            <a:endParaRPr lang="en-US" sz="1100" dirty="0"/>
+          </a:p>
+        </p:txBody>
+      </p:sp>
+      <p:sp>
+        <p:nvSpPr>
+          <p:cNvPr id="9" name="Stat1"/>
+          <p:cNvSpPr/>
+          <p:nvPr/>
+        </p:nvSpPr>
+        <p:spPr>
+          <a:xfrm>
+            <a:off x="2267712" y="1280160"/>
+            <a:ext cx="1463040" cy="640080"/>
+          </a:xfrm>
+          <a:prstGeom prst="rect">
+            <a:avLst/>
+          </a:prstGeom>
+          <a:noFill/>
+          <a:ln/>
+        </p:spPr>
+        <p:txBody>
+          <a:bodyPr wrap="square" lIns="0" tIns="0" rIns="0" bIns="0" rtlCol="0" anchor="ctr"/>
+          <a:lstStyle/>
+          <a:p>
+            <a:pPr algn="ctr" indent="0" marL="0">
+              <a:buNone/>
+            </a:pPr>
+            <a:r>
+              <a:rPr lang="en-US" sz="3600" b="1" dirty="0">
+                <a:solidFill>
+                  <a:srgbClr val="0891B2"/>
+                </a:solidFill>
+                <a:latin typeface="Arial" pitchFamily="34" charset="0"/>
+                <a:ea typeface="Arial" pitchFamily="34" charset="-122"/>
+                <a:cs typeface="Arial" pitchFamily="34" charset="-120"/>
+              </a:rPr>
+              <a:t>8</a:t>
+            </a:r>
+            <a:endParaRPr lang="en-US" sz="3600" dirty="0"/>
+          </a:p>
+        </p:txBody>
+      </p:sp>
+      <p:sp>
+        <p:nvSpPr>
+          <p:cNvPr id="10" name="StatLabel1"/>
+          <p:cNvSpPr/>
+          <p:nvPr/>
+        </p:nvSpPr>
+        <p:spPr>
+          <a:xfrm>
+            <a:off x="2267712" y="1874520"/>
+            <a:ext cx="1463040" cy="274320"/>
+          </a:xfrm>
+          <a:prstGeom prst="rect">
+            <a:avLst/>
+          </a:prstGeom>
+          <a:noFill/>
+          <a:ln/>
+        </p:spPr>
+        <p:txBody>
+          <a:bodyPr wrap="square" lIns="0" tIns="0" rIns="0" bIns="0" rtlCol="0" anchor="ctr"/>
+          <a:lstStyle/>
+          <a:p>
+            <a:pPr algn="ctr" indent="0" marL="0">
+              <a:buNone/>
+            </a:pPr>
+            <a:r>
+              <a:rPr lang="en-US" sz="1100" dirty="0">
+                <a:solidFill>
+                  <a:srgbClr val="6B7280"/>
+                </a:solidFill>
+                <a:latin typeface="Arial" pitchFamily="34" charset="0"/>
+                <a:ea typeface="Arial" pitchFamily="34" charset="-122"/>
+                <a:cs typeface="Arial" pitchFamily="34" charset="-120"/>
+              </a:rPr>
+              <a:t>walk-in shops</a:t>
+            </a:r>
+            <a:endParaRPr lang="en-US" sz="1100" dirty="0"/>
+          </a:p>
+        </p:txBody>
+      </p:sp>
+      <p:sp>
+        <p:nvSpPr>
+          <p:cNvPr id="11" name="Stat2"/>
+          <p:cNvSpPr/>
+          <p:nvPr/>
+        </p:nvSpPr>
+        <p:spPr>
+          <a:xfrm>
+            <a:off x="3895344" y="1280160"/>
+            <a:ext cx="1463040" cy="640080"/>
+          </a:xfrm>
+          <a:prstGeom prst="rect">
+            <a:avLst/>
+          </a:prstGeom>
+          <a:noFill/>
+          <a:ln/>
+        </p:spPr>
+        <p:txBody>
+          <a:bodyPr wrap="square" lIns="0" tIns="0" rIns="0" bIns="0" rtlCol="0" anchor="ctr"/>
+          <a:lstStyle/>
+          <a:p>
+            <a:pPr algn="ctr" indent="0" marL="0">
+              <a:buNone/>
+            </a:pPr>
+            <a:r>
+              <a:rPr lang="en-US" sz="3600" b="1" dirty="0">
+                <a:solidFill>
+                  <a:srgbClr val="0891B2"/>
+                </a:solidFill>
+                <a:latin typeface="Arial" pitchFamily="34" charset="0"/>
+                <a:ea typeface="Arial" pitchFamily="34" charset="-122"/>
+                <a:cs typeface="Arial" pitchFamily="34" charset="-120"/>
+              </a:rPr>
+              <a:t>4</a:t>
+            </a:r>
+            <a:endParaRPr lang="en-US" sz="3600" dirty="0"/>
+          </a:p>
+        </p:txBody>
+      </p:sp>
+      <p:sp>
+        <p:nvSpPr>
+          <p:cNvPr id="12" name="StatLabel2"/>
+          <p:cNvSpPr/>
+          <p:nvPr/>
+        </p:nvSpPr>
+        <p:spPr>
+          <a:xfrm>
+            <a:off x="3895344" y="1874520"/>
+            <a:ext cx="1463040" cy="274320"/>
+          </a:xfrm>
+          <a:prstGeom prst="rect">
+            <a:avLst/>
+          </a:prstGeom>
+          <a:noFill/>
+          <a:ln/>
+        </p:spPr>
+        <p:txBody>
+          <a:bodyPr wrap="square" lIns="0" tIns="0" rIns="0" bIns="0" rtlCol="0" anchor="ctr"/>
+          <a:lstStyle/>
+          <a:p>
+            <a:pPr algn="ctr" indent="0" marL="0">
+              <a:buNone/>
+            </a:pPr>
+            <a:r>
+              <a:rPr lang="en-US" sz="1100" dirty="0">
+                <a:solidFill>
+                  <a:srgbClr val="6B7280"/>
+                </a:solidFill>
+                <a:latin typeface="Arial" pitchFamily="34" charset="0"/>
+                <a:ea typeface="Arial" pitchFamily="34" charset="-122"/>
+                <a:cs typeface="Arial" pitchFamily="34" charset="-120"/>
+              </a:rPr>
+              <a:t>channels</a:t>
+            </a:r>
+            <a:endParaRPr lang="en-US" sz="1100" dirty="0"/>
+          </a:p>
+        </p:txBody>
+      </p:sp>
+      <p:sp>
+        <p:nvSpPr>
+          <p:cNvPr id="13" name="Stat3"/>
+          <p:cNvSpPr/>
+          <p:nvPr/>
+        </p:nvSpPr>
+        <p:spPr>
+          <a:xfrm>
+            <a:off x="5522976" y="1280160"/>
+            <a:ext cx="1463040" cy="640080"/>
+          </a:xfrm>
+          <a:prstGeom prst="rect">
+            <a:avLst/>
+          </a:prstGeom>
+          <a:noFill/>
+          <a:ln/>
+        </p:spPr>
+        <p:txBody>
+          <a:bodyPr wrap="square" lIns="0" tIns="0" rIns="0" bIns="0" rtlCol="0" anchor="ctr"/>
+          <a:lstStyle/>
+          <a:p>
+            <a:pPr algn="ctr" indent="0" marL="0">
+              <a:buNone/>
+            </a:pPr>
+            <a:r>
+              <a:rPr lang="en-US" sz="3600" b="1" dirty="0">
+                <a:solidFill>
+                  <a:srgbClr val="0891B2"/>
+                </a:solidFill>
+                <a:latin typeface="Arial" pitchFamily="34" charset="0"/>
+                <a:ea typeface="Arial" pitchFamily="34" charset="-122"/>
+                <a:cs typeface="Arial" pitchFamily="34" charset="-120"/>
+              </a:rPr>
+              <a:t>8</a:t>
+            </a:r>
+            <a:endParaRPr lang="en-US" sz="3600" dirty="0"/>
+          </a:p>
+        </p:txBody>
+      </p:sp>
+      <p:sp>
+        <p:nvSpPr>
+          <p:cNvPr id="14" name="StatLabel3"/>
+          <p:cNvSpPr/>
+          <p:nvPr/>
+        </p:nvSpPr>
+        <p:spPr>
+          <a:xfrm>
+            <a:off x="5522976" y="1874520"/>
+            <a:ext cx="1463040" cy="274320"/>
+          </a:xfrm>
+          <a:prstGeom prst="rect">
+            <a:avLst/>
+          </a:prstGeom>
+          <a:noFill/>
+          <a:ln/>
+        </p:spPr>
+        <p:txBody>
+          <a:bodyPr wrap="square" lIns="0" tIns="0" rIns="0" bIns="0" rtlCol="0" anchor="ctr"/>
+          <a:lstStyle/>
+          <a:p>
+            <a:pPr algn="ctr" indent="0" marL="0">
+              <a:buNone/>
+            </a:pPr>
+            <a:r>
+              <a:rPr lang="en-US" sz="1100" dirty="0">
+                <a:solidFill>
+                  <a:srgbClr val="6B7280"/>
+                </a:solidFill>
+                <a:latin typeface="Arial" pitchFamily="34" charset="0"/>
+                <a:ea typeface="Arial" pitchFamily="34" charset="-122"/>
+                <a:cs typeface="Arial" pitchFamily="34" charset="-120"/>
+              </a:rPr>
+              <a:t>promotions</a:t>
+            </a:r>
+            <a:endParaRPr lang="en-US" sz="1100" dirty="0"/>
+          </a:p>
+        </p:txBody>
+      </p:sp>
+      <p:sp>
+        <p:nvSpPr>
+          <p:cNvPr id="15" name="Stat4"/>
+          <p:cNvSpPr/>
+          <p:nvPr/>
+        </p:nvSpPr>
+        <p:spPr>
+          <a:xfrm>
+            <a:off x="7150608" y="1280160"/>
+            <a:ext cx="1463040" cy="640080"/>
+          </a:xfrm>
+          <a:prstGeom prst="rect">
+            <a:avLst/>
+          </a:prstGeom>
+          <a:noFill/>
+          <a:ln/>
+        </p:spPr>
+        <p:txBody>
+          <a:bodyPr wrap="square" lIns="0" tIns="0" rIns="0" bIns="0" rtlCol="0" anchor="ctr"/>
+          <a:lstStyle/>
+          <a:p>
+            <a:pPr algn="ctr" indent="0" marL="0">
+              <a:buNone/>
+            </a:pPr>
+            <a:r>
+              <a:rPr lang="en-US" sz="3600" b="1" dirty="0">
+                <a:solidFill>
+                  <a:srgbClr val="0891B2"/>
+                </a:solidFill>
+                <a:latin typeface="Arial" pitchFamily="34" charset="0"/>
+                <a:ea typeface="Arial" pitchFamily="34" charset="-122"/>
+                <a:cs typeface="Arial" pitchFamily="34" charset="-120"/>
+              </a:rPr>
+              <a:t>5K</a:t>
+            </a:r>
+            <a:endParaRPr lang="en-US" sz="3600" dirty="0"/>
+          </a:p>
+        </p:txBody>
+      </p:sp>
+      <p:sp>
+        <p:nvSpPr>
+          <p:cNvPr id="16" name="StatLabel4"/>
+          <p:cNvSpPr/>
+          <p:nvPr/>
+        </p:nvSpPr>
+        <p:spPr>
+          <a:xfrm>
+            <a:off x="7150608" y="1874520"/>
+            <a:ext cx="1463040" cy="274320"/>
+          </a:xfrm>
+          <a:prstGeom prst="rect">
+            <a:avLst/>
+          </a:prstGeom>
+          <a:noFill/>
+          <a:ln/>
+        </p:spPr>
+        <p:txBody>
+          <a:bodyPr wrap="square" lIns="0" tIns="0" rIns="0" bIns="0" rtlCol="0" anchor="ctr"/>
+          <a:lstStyle/>
+          <a:p>
+            <a:pPr algn="ctr" indent="0" marL="0">
+              <a:buNone/>
+            </a:pPr>
+            <a:r>
+              <a:rPr lang="en-US" sz="1100" dirty="0">
+                <a:solidFill>
+                  <a:srgbClr val="6B7280"/>
+                </a:solidFill>
+                <a:latin typeface="Arial" pitchFamily="34" charset="0"/>
+                <a:ea typeface="Arial" pitchFamily="34" charset="-122"/>
+                <a:cs typeface="Arial" pitchFamily="34" charset="-120"/>
+              </a:rPr>
+              <a:t>loyalty members</a:t>
+            </a:r>
+            <a:endParaRPr lang="en-US" sz="1100" dirty="0"/>
+          </a:p>
+        </p:txBody>
+      </p:sp>
+      <p:sp>
+        <p:nvSpPr>
+          <p:cNvPr id="17" name="Body"/>
+          <p:cNvSpPr/>
+          <p:nvPr/>
+        </p:nvSpPr>
+        <p:spPr>
+          <a:xfrm>
+            <a:off x="640080" y="2468880"/>
+            <a:ext cx="7863840" cy="1097280"/>
+          </a:xfrm>
+          <a:prstGeom prst="rect">
+            <a:avLst/>
+          </a:prstGeom>
+          <a:noFill/>
+          <a:ln/>
+        </p:spPr>
+        <p:txBody>
+          <a:bodyPr wrap="square" lIns="0" tIns="0" rIns="0" bIns="0" rtlCol="0" anchor="t"/>
+          <a:lstStyle/>
+          <a:p>
+            <a:pPr indent="0" marL="0">
+              <a:buNone/>
+            </a:pPr>
+            <a:r>
+              <a:rPr lang="en-US" sz="1300" dirty="0">
+                <a:solidFill>
+                  <a:srgbClr val="374151"/>
+                </a:solidFill>
+                <a:latin typeface="Arial" pitchFamily="34" charset="0"/>
+                <a:ea typeface="Arial" pitchFamily="34" charset="-122"/>
+                <a:cs typeface="Arial" pitchFamily="34" charset="-120"/>
+              </a:rPr>
+              <a:t>Twelve branches across central Bangkok in two formats: drive-thrus on outer roads (Ratchada, Ramkhamhaeng, Bangna, Rama 9) and walk-in shops in higher-prestige central districts (Asoke, Sukhumvit 24, Thonglor, Ekkamai, Silom, Sathorn, Ari, Phra Khanong). Customers reach Brew Lab through four channels — dine-in, takeaway, app pickup, and delivery — with a loyalty program (~5,000 active members) tying repeat behavior together. Eight promotions ran across the year, ending with the Comeback 50 voucher to win lapsed members back.</a:t>
+            </a:r>
+            <a:endParaRPr lang="en-US" sz="1300" dirty="0"/>
+          </a:p>
+        </p:txBody>
+      </p:sp>
+      <p:sp>
+        <p:nvSpPr>
+          <p:cNvPr id="18" name="CalloutBg"/>
+          <p:cNvSpPr/>
+          <p:nvPr/>
+        </p:nvSpPr>
+        <p:spPr>
+          <a:xfrm>
+            <a:off x="640080" y="3840480"/>
+            <a:ext cx="7863840" cy="594360"/>
+          </a:xfrm>
+          <a:prstGeom prst="rect">
+            <a:avLst/>
+          </a:prstGeom>
+          <a:solidFill>
+            <a:srgbClr val="E0F7FA"/>
+          </a:solidFill>
+          <a:ln w="12700">
+            <a:solidFill>
+              <a:srgbClr val="0891B2"/>
+            </a:solidFill>
+            <a:prstDash val="solid"/>
+          </a:ln>
+        </p:spPr>
+      </p:sp>
+      <p:sp>
+        <p:nvSpPr>
+          <p:cNvPr id="19" name="Callout"/>
+          <p:cNvSpPr/>
+          <p:nvPr/>
+        </p:nvSpPr>
+        <p:spPr>
+          <a:xfrm>
+            <a:off x="822960" y="3886200"/>
+            <a:ext cx="7498080" cy="502920"/>
+          </a:xfrm>
+          <a:prstGeom prst="rect">
+            <a:avLst/>
+          </a:prstGeom>
+          <a:noFill/>
+          <a:ln/>
+        </p:spPr>
+        <p:txBody>
+          <a:bodyPr wrap="square" lIns="0" tIns="0" rIns="0" bIns="0" rtlCol="0" anchor="ctr"/>
+          <a:lstStyle/>
+          <a:p>
+            <a:pPr indent="0" marL="0">
+              <a:buNone/>
+            </a:pPr>
+            <a:r>
+              <a:rPr lang="en-US" sz="1200" i="1" dirty="0">
+                <a:solidFill>
+                  <a:srgbClr val="1F2937"/>
+                </a:solidFill>
+                <a:latin typeface="Arial" pitchFamily="34" charset="0"/>
+                <a:ea typeface="Arial" pitchFamily="34" charset="-122"/>
+                <a:cs typeface="Arial" pitchFamily="34" charset="-120"/>
+              </a:rPr>
+              <a:t>Khun Ploy is COO. She owns operations across all 12 branches and answers to the founders for revenue, retention, and customer experience.</a:t>
+            </a:r>
+            <a:endParaRPr lang="en-US" sz="1200" dirty="0"/>
+          </a:p>
+        </p:txBody>
+      </p:sp>
+    </p:spTree>
+  </p:cSld>
+  <p:clrMapOvr>
+    <a:masterClrMapping/>
+  </p:clrMapOvr>
+</p:sld>
+</file>
+
+<file path=ppt/slides/slide32.xml><?xml version="1.0" encoding="utf-8"?>
+<p:sld xmlns:a="http://schemas.openxmlformats.org/drawingml/2006/main" xmlns:r="http://schemas.openxmlformats.org/officeDocument/2006/relationships" xmlns:p="http://schemas.openxmlformats.org/presentationml/2006/main">
+  <p:cSld name="Slide 32 — data tables">
+    <p:bg>
+      <p:bgPr>
+        <a:solidFill>
+          <a:srgbClr val="FFFFFF"/>
+        </a:solidFill>
+      </p:bgPr>
+    </p:bg>
+    <p:spTree>
+      <p:nvGrpSpPr>
+        <p:cNvPr id="1" name=""/>
+        <p:cNvGrpSpPr/>
+        <p:nvPr/>
+      </p:nvGrpSpPr>
+      <p:grpSpPr>
+        <a:xfrm>
+          <a:off x="0" y="0"/>
+          <a:ext cx="0" cy="0"/>
+          <a:chOff x="0" y="0"/>
+          <a:chExt cx="0" cy="0"/>
+        </a:xfrm>
+      </p:grpSpPr>
+      <p:sp>
+        <p:nvSpPr>
+          <p:cNvPr id="2" name="Shape 0"/>
+          <p:cNvSpPr/>
+          <p:nvPr/>
+        </p:nvSpPr>
+        <p:spPr>
+          <a:xfrm>
+            <a:off x="0" y="0"/>
+            <a:ext cx="9144000" cy="45720"/>
+          </a:xfrm>
+          <a:prstGeom prst="rect">
+            <a:avLst/>
+          </a:prstGeom>
+          <a:solidFill>
+            <a:srgbClr val="0891B2"/>
+          </a:solidFill>
+          <a:ln/>
+        </p:spPr>
+      </p:sp>
+      <p:sp>
+        <p:nvSpPr>
+          <p:cNvPr id="3" name="Footer"/>
+          <p:cNvSpPr/>
+          <p:nvPr/>
+        </p:nvSpPr>
+        <p:spPr>
+          <a:xfrm>
+            <a:off x="640080" y="4828032"/>
+            <a:ext cx="5486400" cy="228600"/>
+          </a:xfrm>
+          <a:prstGeom prst="rect">
+            <a:avLst/>
+          </a:prstGeom>
+          <a:noFill/>
+          <a:ln/>
+        </p:spPr>
+        <p:txBody>
+          <a:bodyPr wrap="square" lIns="0" tIns="0" rIns="0" bIns="0" rtlCol="0" anchor="ctr"/>
+          <a:lstStyle/>
+          <a:p>
+            <a:pPr indent="0" marL="0">
+              <a:buNone/>
+            </a:pPr>
+            <a:r>
+              <a:rPr lang="en-US" sz="900" dirty="0">
+                <a:solidFill>
+                  <a:srgbClr val="9CA3AF"/>
+                </a:solidFill>
+                <a:latin typeface="Arial" pitchFamily="34" charset="0"/>
+                <a:ea typeface="Arial" pitchFamily="34" charset="-122"/>
+                <a:cs typeface="Arial" pitchFamily="34" charset="-120"/>
+              </a:rPr>
+              <a:t>NIDA  |  MADT6004  |  Setup</a:t>
+            </a:r>
+            <a:endParaRPr lang="en-US" sz="900" dirty="0"/>
+          </a:p>
+        </p:txBody>
+      </p:sp>
+      <p:sp>
+        <p:nvSpPr>
+          <p:cNvPr id="4" name="Badge"/>
+          <p:cNvSpPr/>
+          <p:nvPr/>
+        </p:nvSpPr>
+        <p:spPr>
+          <a:xfrm>
+            <a:off x="7772400" y="4800600"/>
+            <a:ext cx="914400" cy="274320"/>
+          </a:xfrm>
+          <a:prstGeom prst="rect">
+            <a:avLst/>
+          </a:prstGeom>
+          <a:noFill/>
+          <a:ln/>
+        </p:spPr>
+        <p:txBody>
+          <a:bodyPr wrap="square" lIns="0" tIns="0" rIns="0" bIns="0" rtlCol="0" anchor="ctr"/>
+          <a:lstStyle/>
+          <a:p>
+            <a:pPr algn="r" indent="0" marL="0">
+              <a:buNone/>
+            </a:pPr>
+            <a:r>
+              <a:rPr lang="en-US" sz="1200" b="1" dirty="0">
+                <a:solidFill>
+                  <a:srgbClr val="0891B2"/>
+                </a:solidFill>
+                <a:latin typeface="Arial" pitchFamily="34" charset="0"/>
+                <a:ea typeface="Arial" pitchFamily="34" charset="-122"/>
+                <a:cs typeface="Arial" pitchFamily="34" charset="-120"/>
+              </a:rPr>
+              <a:t>MADT</a:t>
+            </a:r>
+            <a:endParaRPr lang="en-US" sz="1200" dirty="0"/>
+          </a:p>
+        </p:txBody>
+      </p:sp>
+      <p:sp>
+        <p:nvSpPr>
+          <p:cNvPr id="5" name="Title"/>
+          <p:cNvSpPr/>
+          <p:nvPr/>
+        </p:nvSpPr>
+        <p:spPr>
+          <a:xfrm>
+            <a:off x="640080" y="274320"/>
+            <a:ext cx="7863840" cy="502920"/>
+          </a:xfrm>
+          <a:prstGeom prst="rect">
+            <a:avLst/>
+          </a:prstGeom>
+          <a:noFill/>
+          <a:ln/>
+        </p:spPr>
+        <p:txBody>
+          <a:bodyPr wrap="square" lIns="0" tIns="0" rIns="0" bIns="0" rtlCol="0" anchor="ctr"/>
+          <a:lstStyle/>
+          <a:p>
+            <a:pPr indent="0" marL="0">
+              <a:buNone/>
+            </a:pPr>
+            <a:r>
+              <a:rPr lang="en-US" sz="2800" b="1" dirty="0">
+                <a:solidFill>
+                  <a:srgbClr val="1F2937"/>
+                </a:solidFill>
+                <a:latin typeface="Arial" pitchFamily="34" charset="0"/>
+                <a:ea typeface="Arial" pitchFamily="34" charset="-122"/>
+                <a:cs typeface="Arial" pitchFamily="34" charset="-120"/>
+              </a:rPr>
+              <a:t>What's inside data/brewlab.db</a:t>
+            </a:r>
+            <a:endParaRPr lang="en-US" sz="2800" dirty="0"/>
+          </a:p>
+        </p:txBody>
+      </p:sp>
+      <p:sp>
+        <p:nvSpPr>
+          <p:cNvPr id="6" name="Subtitle"/>
+          <p:cNvSpPr/>
+          <p:nvPr/>
+        </p:nvSpPr>
+        <p:spPr>
+          <a:xfrm>
+            <a:off x="640080" y="777240"/>
+            <a:ext cx="7863840" cy="274320"/>
+          </a:xfrm>
+          <a:prstGeom prst="rect">
+            <a:avLst/>
+          </a:prstGeom>
+          <a:noFill/>
+          <a:ln/>
+        </p:spPr>
+        <p:txBody>
+          <a:bodyPr wrap="square" lIns="0" tIns="0" rIns="0" bIns="0" rtlCol="0" anchor="ctr"/>
+          <a:lstStyle/>
+          <a:p>
+            <a:pPr indent="0" marL="0">
+              <a:buNone/>
+            </a:pPr>
+            <a:r>
+              <a:rPr lang="en-US" sz="1300" i="1" dirty="0">
+                <a:solidFill>
+                  <a:srgbClr val="6B7280"/>
+                </a:solidFill>
+                <a:latin typeface="Arial" pitchFamily="34" charset="0"/>
+                <a:ea typeface="Arial" pitchFamily="34" charset="-122"/>
+                <a:cs typeface="Arial" pitchFamily="34" charset="-120"/>
+              </a:rPr>
+              <a:t>Nine tables — twelve months of operations</a:t>
+            </a:r>
+            <a:endParaRPr lang="en-US" sz="1300" dirty="0"/>
+          </a:p>
+        </p:txBody>
+      </p:sp>
+      <p:sp>
+        <p:nvSpPr>
+          <p:cNvPr id="7" name="HdrBg"/>
+          <p:cNvSpPr/>
+          <p:nvPr/>
+        </p:nvSpPr>
+        <p:spPr>
+          <a:xfrm>
+            <a:off x="640080" y="1230000"/>
+            <a:ext cx="7860000" cy="320000"/>
+          </a:xfrm>
+          <a:prstGeom prst="rect">
+            <a:avLst/>
+          </a:prstGeom>
+          <a:solidFill>
+            <a:srgbClr val="0891B2"/>
+          </a:solidFill>
+          <a:ln/>
+        </p:spPr>
+      </p:sp>
+      <p:sp>
+        <p:nvSpPr>
+          <p:cNvPr id="8" name="Hdr_Table"/>
+          <p:cNvSpPr/>
+          <p:nvPr/>
+        </p:nvSpPr>
+        <p:spPr>
+          <a:xfrm>
+            <a:off x="690080" y="1230000"/>
+            <a:ext cx="1850000" cy="320000"/>
+          </a:xfrm>
+          <a:prstGeom prst="rect">
+            <a:avLst/>
+          </a:prstGeom>
+          <a:noFill/>
+          <a:ln/>
+        </p:spPr>
+        <p:txBody>
+          <a:bodyPr wrap="square" lIns="0" tIns="0" rIns="0" bIns="0" rtlCol="0" anchor="ctr"/>
+          <a:lstStyle/>
+          <a:p>
+            <a:pPr indent="0" marL="0">
+              <a:buNone/>
+            </a:pPr>
+            <a:r>
+              <a:rPr lang="en-US" sz="1100" b="1" dirty="0">
+                <a:solidFill>
+                  <a:srgbClr val="FFFFFF"/>
+                </a:solidFill>
+                <a:latin typeface="Arial" pitchFamily="34" charset="0"/>
+                <a:ea typeface="Arial" pitchFamily="34" charset="-122"/>
+                <a:cs typeface="Arial" pitchFamily="34" charset="-120"/>
+              </a:rPr>
+              <a:t>Table</a:t>
+            </a:r>
+            <a:endParaRPr lang="en-US" sz="1100" dirty="0"/>
+          </a:p>
+        </p:txBody>
+      </p:sp>
+      <p:sp>
+        <p:nvSpPr>
+          <p:cNvPr id="9" name="Hdr_Rows"/>
+          <p:cNvSpPr/>
+          <p:nvPr/>
+        </p:nvSpPr>
+        <p:spPr>
+          <a:xfrm>
+            <a:off x="2690080" y="1230000"/>
+            <a:ext cx="850000" cy="320000"/>
+          </a:xfrm>
+          <a:prstGeom prst="rect">
+            <a:avLst/>
+          </a:prstGeom>
+          <a:noFill/>
+          <a:ln/>
+        </p:spPr>
+        <p:txBody>
+          <a:bodyPr wrap="square" lIns="0" tIns="0" rIns="0" bIns="0" rtlCol="0" anchor="ctr"/>
+          <a:lstStyle/>
+          <a:p>
+            <a:pPr indent="0" marL="0">
+              <a:buNone/>
+            </a:pPr>
+            <a:r>
+              <a:rPr lang="en-US" sz="1100" b="1" dirty="0">
+                <a:solidFill>
+                  <a:srgbClr val="FFFFFF"/>
+                </a:solidFill>
+                <a:latin typeface="Arial" pitchFamily="34" charset="0"/>
+                <a:ea typeface="Arial" pitchFamily="34" charset="-122"/>
+                <a:cs typeface="Arial" pitchFamily="34" charset="-120"/>
+              </a:rPr>
+              <a:t>Rows</a:t>
+            </a:r>
+            <a:endParaRPr lang="en-US" sz="1100" dirty="0"/>
+          </a:p>
+        </p:txBody>
+      </p:sp>
+      <p:sp>
+        <p:nvSpPr>
+          <p:cNvPr id="10" name="Hdr_What's in it"/>
+          <p:cNvSpPr/>
+          <p:nvPr/>
+        </p:nvSpPr>
+        <p:spPr>
+          <a:xfrm>
+            <a:off x="3690080" y="1230000"/>
+            <a:ext cx="4810000" cy="320000"/>
+          </a:xfrm>
+          <a:prstGeom prst="rect">
+            <a:avLst/>
+          </a:prstGeom>
+          <a:noFill/>
+          <a:ln/>
+        </p:spPr>
+        <p:txBody>
+          <a:bodyPr wrap="square" lIns="0" tIns="0" rIns="0" bIns="0" rtlCol="0" anchor="ctr"/>
+          <a:lstStyle/>
+          <a:p>
+            <a:pPr indent="0" marL="0">
+              <a:buNone/>
+            </a:pPr>
+            <a:r>
+              <a:rPr lang="en-US" sz="1100" b="1" dirty="0">
+                <a:solidFill>
+                  <a:srgbClr val="FFFFFF"/>
+                </a:solidFill>
+                <a:latin typeface="Arial" pitchFamily="34" charset="0"/>
+                <a:ea typeface="Arial" pitchFamily="34" charset="-122"/>
+                <a:cs typeface="Arial" pitchFamily="34" charset="-120"/>
+              </a:rPr>
+              <a:t>What's in it</a:t>
+            </a:r>
+            <a:endParaRPr lang="en-US" sz="1100" dirty="0"/>
+          </a:p>
+        </p:txBody>
+      </p:sp>
+      <p:sp>
+        <p:nvSpPr>
+          <p:cNvPr id="11" name="Name0"/>
+          <p:cNvSpPr/>
+          <p:nvPr/>
+        </p:nvSpPr>
+        <p:spPr>
+          <a:xfrm>
+            <a:off x="690080" y="1550000"/>
+            <a:ext cx="1850000" cy="290000"/>
+          </a:xfrm>
+          <a:prstGeom prst="rect">
+            <a:avLst/>
+          </a:prstGeom>
+          <a:noFill/>
+          <a:ln/>
+        </p:spPr>
+        <p:txBody>
+          <a:bodyPr wrap="square" lIns="0" tIns="0" rIns="0" bIns="0" rtlCol="0" anchor="ctr"/>
+          <a:lstStyle/>
+          <a:p>
+            <a:pPr indent="0" marL="0">
+              <a:buNone/>
+            </a:pPr>
+            <a:r>
+              <a:rPr lang="en-US" sz="1100" b="1" dirty="0">
+                <a:solidFill>
+                  <a:srgbClr val="0891B2"/>
+                </a:solidFill>
+                <a:latin typeface="Consolas" pitchFamily="49" charset="0"/>
+              </a:rPr>
+              <a:t>branches</a:t>
+            </a:r>
+          </a:p>
+        </p:txBody>
+      </p:sp>
+      <p:sp>
+        <p:nvSpPr>
+          <p:cNvPr id="12" name="Rows0"/>
+          <p:cNvSpPr/>
+          <p:nvPr/>
+        </p:nvSpPr>
+        <p:spPr>
+          <a:xfrm>
+            <a:off x="2640080" y="1550000"/>
+            <a:ext cx="900000" cy="290000"/>
+          </a:xfrm>
+          <a:prstGeom prst="rect">
+            <a:avLst/>
+          </a:prstGeom>
+          <a:noFill/>
+          <a:ln/>
+        </p:spPr>
+        <p:txBody>
+          <a:bodyPr wrap="square" lIns="0" tIns="0" rIns="0" bIns="0" rtlCol="0" anchor="ctr"/>
+          <a:lstStyle/>
+          <a:p>
+            <a:pPr indent="0" marL="0">
+              <a:buNone/>
+            </a:pPr>
+            <a:r>
+              <a:rPr lang="en-US" sz="1100" dirty="0">
+                <a:solidFill>
+                  <a:srgbClr val="374151"/>
+                </a:solidFill>
+                <a:latin typeface="Arial" pitchFamily="34" charset="0"/>
+                <a:ea typeface="Arial" pitchFamily="34" charset="-122"/>
+                <a:cs typeface="Arial" pitchFamily="34" charset="-120"/>
+              </a:rPr>
+              <a:t>12</a:t>
+            </a:r>
+            <a:endParaRPr lang="en-US" sz="1100" dirty="0"/>
+          </a:p>
+        </p:txBody>
+      </p:sp>
+      <p:sp>
+        <p:nvSpPr>
+          <p:cNvPr id="13" name="Desc0"/>
+          <p:cNvSpPr/>
+          <p:nvPr/>
+        </p:nvSpPr>
+        <p:spPr>
+          <a:xfrm>
+            <a:off x="3690080" y="1550000"/>
+            <a:ext cx="4810000" cy="290000"/>
+          </a:xfrm>
+          <a:prstGeom prst="rect">
+            <a:avLst/>
+          </a:prstGeom>
+          <a:noFill/>
+          <a:ln/>
+        </p:spPr>
+        <p:txBody>
+          <a:bodyPr wrap="square" lIns="0" tIns="0" rIns="0" bIns="0" rtlCol="0" anchor="ctr"/>
+          <a:lstStyle/>
+          <a:p>
+            <a:pPr indent="0" marL="0">
+              <a:buNone/>
+            </a:pPr>
+            <a:r>
+              <a:rPr lang="en-US" sz="1100" dirty="0">
+                <a:solidFill>
+                  <a:srgbClr val="374151"/>
+                </a:solidFill>
+                <a:latin typeface="Arial" pitchFamily="34" charset="0"/>
+                <a:ea typeface="Arial" pitchFamily="34" charset="-122"/>
+                <a:cs typeface="Arial" pitchFamily="34" charset="-120"/>
+              </a:rPr>
+              <a:t>district, drive-thru, seats, size, base traffic</a:t>
+            </a:r>
+            <a:endParaRPr lang="en-US" sz="1100" dirty="0"/>
+          </a:p>
+        </p:txBody>
+      </p:sp>
+      <p:sp>
+        <p:nvSpPr>
+          <p:cNvPr id="14" name="RowBg1"/>
+          <p:cNvSpPr/>
+          <p:nvPr/>
+        </p:nvSpPr>
+        <p:spPr>
+          <a:xfrm>
+            <a:off x="640080" y="1840000"/>
+            <a:ext cx="7860000" cy="290000"/>
+          </a:xfrm>
+          <a:prstGeom prst="rect">
+            <a:avLst/>
+          </a:prstGeom>
+          <a:solidFill>
+            <a:srgbClr val="F3F4F6"/>
+          </a:solidFill>
+          <a:ln/>
+        </p:spPr>
+      </p:sp>
+      <p:sp>
+        <p:nvSpPr>
+          <p:cNvPr id="15" name="Name1"/>
+          <p:cNvSpPr/>
+          <p:nvPr/>
+        </p:nvSpPr>
+        <p:spPr>
+          <a:xfrm>
+            <a:off x="690080" y="1840000"/>
+            <a:ext cx="1850000" cy="290000"/>
+          </a:xfrm>
+          <a:prstGeom prst="rect">
+            <a:avLst/>
+          </a:prstGeom>
+          <a:noFill/>
+          <a:ln/>
+        </p:spPr>
+        <p:txBody>
+          <a:bodyPr wrap="square" lIns="0" tIns="0" rIns="0" bIns="0" rtlCol="0" anchor="ctr"/>
+          <a:lstStyle/>
+          <a:p>
+            <a:pPr indent="0" marL="0">
+              <a:buNone/>
+            </a:pPr>
+            <a:r>
+              <a:rPr lang="en-US" sz="1100" b="1" dirty="0">
+                <a:solidFill>
+                  <a:srgbClr val="0891B2"/>
+                </a:solidFill>
+                <a:latin typeface="Consolas" pitchFamily="49" charset="0"/>
+              </a:rPr>
+              <a:t>customers</a:t>
+            </a:r>
+          </a:p>
+        </p:txBody>
+      </p:sp>
+      <p:sp>
+        <p:nvSpPr>
+          <p:cNvPr id="16" name="Rows1"/>
+          <p:cNvSpPr/>
+          <p:nvPr/>
+        </p:nvSpPr>
+        <p:spPr>
+          <a:xfrm>
+            <a:off x="2640080" y="1840000"/>
+            <a:ext cx="900000" cy="290000"/>
+          </a:xfrm>
+          <a:prstGeom prst="rect">
+            <a:avLst/>
+          </a:prstGeom>
+          <a:noFill/>
+          <a:ln/>
+        </p:spPr>
+        <p:txBody>
+          <a:bodyPr wrap="square" lIns="0" tIns="0" rIns="0" bIns="0" rtlCol="0" anchor="ctr"/>
+          <a:lstStyle/>
+          <a:p>
+            <a:pPr indent="0" marL="0">
+              <a:buNone/>
+            </a:pPr>
+            <a:r>
+              <a:rPr lang="en-US" sz="1100" dirty="0">
+                <a:solidFill>
+                  <a:srgbClr val="374151"/>
+                </a:solidFill>
+                <a:latin typeface="Arial" pitchFamily="34" charset="0"/>
+                <a:ea typeface="Arial" pitchFamily="34" charset="-122"/>
+                <a:cs typeface="Arial" pitchFamily="34" charset="-120"/>
+              </a:rPr>
+              <a:t>5,000</a:t>
+            </a:r>
+            <a:endParaRPr lang="en-US" sz="1100" dirty="0"/>
+          </a:p>
+        </p:txBody>
+      </p:sp>
+      <p:sp>
+        <p:nvSpPr>
+          <p:cNvPr id="17" name="Desc1"/>
+          <p:cNvSpPr/>
+          <p:nvPr/>
+        </p:nvSpPr>
+        <p:spPr>
+          <a:xfrm>
+            <a:off x="3690080" y="1840000"/>
+            <a:ext cx="4810000" cy="290000"/>
+          </a:xfrm>
+          <a:prstGeom prst="rect">
+            <a:avLst/>
+          </a:prstGeom>
+          <a:noFill/>
+          <a:ln/>
+        </p:spPr>
+        <p:txBody>
+          <a:bodyPr wrap="square" lIns="0" tIns="0" rIns="0" bIns="0" rtlCol="0" anchor="ctr"/>
+          <a:lstStyle/>
+          <a:p>
+            <a:pPr indent="0" marL="0">
+              <a:buNone/>
+            </a:pPr>
+            <a:r>
+              <a:rPr lang="en-US" sz="1100" dirty="0">
+                <a:solidFill>
+                  <a:srgbClr val="374151"/>
+                </a:solidFill>
+                <a:latin typeface="Arial" pitchFamily="34" charset="0"/>
+                <a:ea typeface="Arial" pitchFamily="34" charset="-122"/>
+                <a:cs typeface="Arial" pitchFamily="34" charset="-120"/>
+              </a:rPr>
+              <a:t>demographics + acquisition channel + segment label</a:t>
+            </a:r>
+            <a:endParaRPr lang="en-US" sz="1100" dirty="0"/>
+          </a:p>
+        </p:txBody>
+      </p:sp>
+      <p:sp>
+        <p:nvSpPr>
+          <p:cNvPr id="18" name="Name2"/>
+          <p:cNvSpPr/>
+          <p:nvPr/>
+        </p:nvSpPr>
+        <p:spPr>
+          <a:xfrm>
+            <a:off x="690080" y="2130000"/>
+            <a:ext cx="1850000" cy="290000"/>
+          </a:xfrm>
+          <a:prstGeom prst="rect">
+            <a:avLst/>
+          </a:prstGeom>
+          <a:noFill/>
+          <a:ln/>
+        </p:spPr>
+        <p:txBody>
+          <a:bodyPr wrap="square" lIns="0" tIns="0" rIns="0" bIns="0" rtlCol="0" anchor="ctr"/>
+          <a:lstStyle/>
+          <a:p>
+            <a:pPr indent="0" marL="0">
+              <a:buNone/>
+            </a:pPr>
+            <a:r>
+              <a:rPr lang="en-US" sz="1100" b="1" dirty="0">
+                <a:solidFill>
+                  <a:srgbClr val="0891B2"/>
+                </a:solidFill>
+                <a:latin typeface="Consolas" pitchFamily="49" charset="0"/>
+              </a:rPr>
+              <a:t>products</a:t>
+            </a:r>
+          </a:p>
+        </p:txBody>
+      </p:sp>
+      <p:sp>
+        <p:nvSpPr>
+          <p:cNvPr id="19" name="Rows2"/>
+          <p:cNvSpPr/>
+          <p:nvPr/>
+        </p:nvSpPr>
+        <p:spPr>
+          <a:xfrm>
+            <a:off x="2640080" y="2130000"/>
+            <a:ext cx="900000" cy="290000"/>
+          </a:xfrm>
+          <a:prstGeom prst="rect">
+            <a:avLst/>
+          </a:prstGeom>
+          <a:noFill/>
+          <a:ln/>
+        </p:spPr>
+        <p:txBody>
+          <a:bodyPr wrap="square" lIns="0" tIns="0" rIns="0" bIns="0" rtlCol="0" anchor="ctr"/>
+          <a:lstStyle/>
+          <a:p>
+            <a:pPr indent="0" marL="0">
+              <a:buNone/>
+            </a:pPr>
+            <a:r>
+              <a:rPr lang="en-US" sz="1100" dirty="0">
+                <a:solidFill>
+                  <a:srgbClr val="374151"/>
+                </a:solidFill>
+                <a:latin typeface="Arial" pitchFamily="34" charset="0"/>
+                <a:ea typeface="Arial" pitchFamily="34" charset="-122"/>
+                <a:cs typeface="Arial" pitchFamily="34" charset="-120"/>
+              </a:rPr>
+              <a:t>40</a:t>
+            </a:r>
+            <a:endParaRPr lang="en-US" sz="1100" dirty="0"/>
+          </a:p>
+        </p:txBody>
+      </p:sp>
+      <p:sp>
+        <p:nvSpPr>
+          <p:cNvPr id="20" name="Desc2"/>
+          <p:cNvSpPr/>
+          <p:nvPr/>
+        </p:nvSpPr>
+        <p:spPr>
+          <a:xfrm>
+            <a:off x="3690080" y="2130000"/>
+            <a:ext cx="4810000" cy="290000"/>
+          </a:xfrm>
+          <a:prstGeom prst="rect">
+            <a:avLst/>
+          </a:prstGeom>
+          <a:noFill/>
+          <a:ln/>
+        </p:spPr>
+        <p:txBody>
+          <a:bodyPr wrap="square" lIns="0" tIns="0" rIns="0" bIns="0" rtlCol="0" anchor="ctr"/>
+          <a:lstStyle/>
+          <a:p>
+            <a:pPr indent="0" marL="0">
+              <a:buNone/>
+            </a:pPr>
+            <a:r>
+              <a:rPr lang="en-US" sz="1100" dirty="0">
+                <a:solidFill>
+                  <a:srgbClr val="374151"/>
+                </a:solidFill>
+                <a:latin typeface="Arial" pitchFamily="34" charset="0"/>
+                <a:ea typeface="Arial" pitchFamily="34" charset="-122"/>
+                <a:cs typeface="Arial" pitchFamily="34" charset="-120"/>
+              </a:rPr>
+              <a:t>coffee, tea, food, dessert, merch — with price + cost</a:t>
+            </a:r>
+            <a:endParaRPr lang="en-US" sz="1100" dirty="0"/>
+          </a:p>
+        </p:txBody>
+      </p:sp>
+      <p:sp>
+        <p:nvSpPr>
+          <p:cNvPr id="21" name="RowBg3"/>
+          <p:cNvSpPr/>
+          <p:nvPr/>
+        </p:nvSpPr>
+        <p:spPr>
+          <a:xfrm>
+            <a:off x="640080" y="2420000"/>
+            <a:ext cx="7860000" cy="290000"/>
+          </a:xfrm>
+          <a:prstGeom prst="rect">
+            <a:avLst/>
+          </a:prstGeom>
+          <a:solidFill>
+            <a:srgbClr val="F3F4F6"/>
+          </a:solidFill>
+          <a:ln/>
+        </p:spPr>
+      </p:sp>
+      <p:sp>
+        <p:nvSpPr>
+          <p:cNvPr id="22" name="Name3"/>
+          <p:cNvSpPr/>
+          <p:nvPr/>
+        </p:nvSpPr>
+        <p:spPr>
+          <a:xfrm>
+            <a:off x="690080" y="2420000"/>
+            <a:ext cx="1850000" cy="290000"/>
+          </a:xfrm>
+          <a:prstGeom prst="rect">
+            <a:avLst/>
+          </a:prstGeom>
+          <a:noFill/>
+          <a:ln/>
+        </p:spPr>
+        <p:txBody>
+          <a:bodyPr wrap="square" lIns="0" tIns="0" rIns="0" bIns="0" rtlCol="0" anchor="ctr"/>
+          <a:lstStyle/>
+          <a:p>
+            <a:pPr indent="0" marL="0">
+              <a:buNone/>
+            </a:pPr>
+            <a:r>
+              <a:rPr lang="en-US" sz="1100" b="1" dirty="0">
+                <a:solidFill>
+                  <a:srgbClr val="0891B2"/>
+                </a:solidFill>
+                <a:latin typeface="Consolas" pitchFamily="49" charset="0"/>
+              </a:rPr>
+              <a:t>transactions</a:t>
+            </a:r>
+          </a:p>
+        </p:txBody>
+      </p:sp>
+      <p:sp>
+        <p:nvSpPr>
+          <p:cNvPr id="23" name="Rows3"/>
+          <p:cNvSpPr/>
+          <p:nvPr/>
+        </p:nvSpPr>
+        <p:spPr>
+          <a:xfrm>
+            <a:off x="2640080" y="2420000"/>
+            <a:ext cx="900000" cy="290000"/>
+          </a:xfrm>
+          <a:prstGeom prst="rect">
+            <a:avLst/>
+          </a:prstGeom>
+          <a:noFill/>
+          <a:ln/>
+        </p:spPr>
+        <p:txBody>
+          <a:bodyPr wrap="square" lIns="0" tIns="0" rIns="0" bIns="0" rtlCol="0" anchor="ctr"/>
+          <a:lstStyle/>
+          <a:p>
+            <a:pPr indent="0" marL="0">
+              <a:buNone/>
+            </a:pPr>
+            <a:r>
+              <a:rPr lang="en-US" sz="1100" dirty="0">
+                <a:solidFill>
+                  <a:srgbClr val="374151"/>
+                </a:solidFill>
+                <a:latin typeface="Arial" pitchFamily="34" charset="0"/>
+                <a:ea typeface="Arial" pitchFamily="34" charset="-122"/>
+                <a:cs typeface="Arial" pitchFamily="34" charset="-120"/>
+              </a:rPr>
+              <a:t>~267,000</a:t>
+            </a:r>
+            <a:endParaRPr lang="en-US" sz="1100" dirty="0"/>
+          </a:p>
+        </p:txBody>
+      </p:sp>
+      <p:sp>
+        <p:nvSpPr>
+          <p:cNvPr id="24" name="Desc3"/>
+          <p:cNvSpPr/>
+          <p:nvPr/>
+        </p:nvSpPr>
+        <p:spPr>
+          <a:xfrm>
+            <a:off x="3690080" y="2420000"/>
+            <a:ext cx="4810000" cy="290000"/>
+          </a:xfrm>
+          <a:prstGeom prst="rect">
+            <a:avLst/>
+          </a:prstGeom>
+          <a:noFill/>
+          <a:ln/>
+        </p:spPr>
+        <p:txBody>
+          <a:bodyPr wrap="square" lIns="0" tIns="0" rIns="0" bIns="0" rtlCol="0" anchor="ctr"/>
+          <a:lstStyle/>
+          <a:p>
+            <a:pPr indent="0" marL="0">
+              <a:buNone/>
+            </a:pPr>
+            <a:r>
+              <a:rPr lang="en-US" sz="1100" dirty="0">
+                <a:solidFill>
+                  <a:srgbClr val="374151"/>
+                </a:solidFill>
+                <a:latin typeface="Arial" pitchFamily="34" charset="0"/>
+                <a:ea typeface="Arial" pitchFamily="34" charset="-122"/>
+                <a:cs typeface="Arial" pitchFamily="34" charset="-120"/>
+              </a:rPr>
+              <a:t>order-level: branch + customer + channel + promo + total</a:t>
+            </a:r>
+            <a:endParaRPr lang="en-US" sz="1100" dirty="0"/>
+          </a:p>
+        </p:txBody>
+      </p:sp>
+      <p:sp>
+        <p:nvSpPr>
+          <p:cNvPr id="25" name="Name4"/>
+          <p:cNvSpPr/>
+          <p:nvPr/>
+        </p:nvSpPr>
+        <p:spPr>
+          <a:xfrm>
+            <a:off x="690080" y="2710000"/>
+            <a:ext cx="1850000" cy="290000"/>
+          </a:xfrm>
+          <a:prstGeom prst="rect">
+            <a:avLst/>
+          </a:prstGeom>
+          <a:noFill/>
+          <a:ln/>
+        </p:spPr>
+        <p:txBody>
+          <a:bodyPr wrap="square" lIns="0" tIns="0" rIns="0" bIns="0" rtlCol="0" anchor="ctr"/>
+          <a:lstStyle/>
+          <a:p>
+            <a:pPr indent="0" marL="0">
+              <a:buNone/>
+            </a:pPr>
+            <a:r>
+              <a:rPr lang="en-US" sz="1100" b="1" dirty="0">
+                <a:solidFill>
+                  <a:srgbClr val="0891B2"/>
+                </a:solidFill>
+                <a:latin typeface="Consolas" pitchFamily="49" charset="0"/>
+              </a:rPr>
+              <a:t>order_items</a:t>
+            </a:r>
+          </a:p>
+        </p:txBody>
+      </p:sp>
+      <p:sp>
+        <p:nvSpPr>
+          <p:cNvPr id="26" name="Rows4"/>
+          <p:cNvSpPr/>
+          <p:nvPr/>
+        </p:nvSpPr>
+        <p:spPr>
+          <a:xfrm>
+            <a:off x="2640080" y="2710000"/>
+            <a:ext cx="900000" cy="290000"/>
+          </a:xfrm>
+          <a:prstGeom prst="rect">
+            <a:avLst/>
+          </a:prstGeom>
+          <a:noFill/>
+          <a:ln/>
+        </p:spPr>
+        <p:txBody>
+          <a:bodyPr wrap="square" lIns="0" tIns="0" rIns="0" bIns="0" rtlCol="0" anchor="ctr"/>
+          <a:lstStyle/>
+          <a:p>
+            <a:pPr indent="0" marL="0">
+              <a:buNone/>
+            </a:pPr>
+            <a:r>
+              <a:rPr lang="en-US" sz="1100" dirty="0">
+                <a:solidFill>
+                  <a:srgbClr val="374151"/>
+                </a:solidFill>
+                <a:latin typeface="Arial" pitchFamily="34" charset="0"/>
+                <a:ea typeface="Arial" pitchFamily="34" charset="-122"/>
+                <a:cs typeface="Arial" pitchFamily="34" charset="-120"/>
+              </a:rPr>
+              <a:t>~362,000</a:t>
+            </a:r>
+            <a:endParaRPr lang="en-US" sz="1100" dirty="0"/>
+          </a:p>
+        </p:txBody>
+      </p:sp>
+      <p:sp>
+        <p:nvSpPr>
+          <p:cNvPr id="27" name="Desc4"/>
+          <p:cNvSpPr/>
+          <p:nvPr/>
+        </p:nvSpPr>
+        <p:spPr>
+          <a:xfrm>
+            <a:off x="3690080" y="2710000"/>
+            <a:ext cx="4810000" cy="290000"/>
+          </a:xfrm>
+          <a:prstGeom prst="rect">
+            <a:avLst/>
+          </a:prstGeom>
+          <a:noFill/>
+          <a:ln/>
+        </p:spPr>
+        <p:txBody>
+          <a:bodyPr wrap="square" lIns="0" tIns="0" rIns="0" bIns="0" rtlCol="0" anchor="ctr"/>
+          <a:lstStyle/>
+          <a:p>
+            <a:pPr indent="0" marL="0">
+              <a:buNone/>
+            </a:pPr>
+            <a:r>
+              <a:rPr lang="en-US" sz="1100" dirty="0">
+                <a:solidFill>
+                  <a:srgbClr val="374151"/>
+                </a:solidFill>
+                <a:latin typeface="Arial" pitchFamily="34" charset="0"/>
+                <a:ea typeface="Arial" pitchFamily="34" charset="-122"/>
+                <a:cs typeface="Arial" pitchFamily="34" charset="-120"/>
+              </a:rPr>
+              <a:t>line-level: product, qty, unit price, line discount</a:t>
+            </a:r>
+            <a:endParaRPr lang="en-US" sz="1100" dirty="0"/>
+          </a:p>
+        </p:txBody>
+      </p:sp>
+      <p:sp>
+        <p:nvSpPr>
+          <p:cNvPr id="28" name="RowBg5"/>
+          <p:cNvSpPr/>
+          <p:nvPr/>
+        </p:nvSpPr>
+        <p:spPr>
+          <a:xfrm>
+            <a:off x="640080" y="3000000"/>
+            <a:ext cx="7860000" cy="290000"/>
+          </a:xfrm>
+          <a:prstGeom prst="rect">
+            <a:avLst/>
+          </a:prstGeom>
+          <a:solidFill>
+            <a:srgbClr val="F3F4F6"/>
+          </a:solidFill>
+          <a:ln/>
+        </p:spPr>
+      </p:sp>
+      <p:sp>
+        <p:nvSpPr>
+          <p:cNvPr id="29" name="Name5"/>
+          <p:cNvSpPr/>
+          <p:nvPr/>
+        </p:nvSpPr>
+        <p:spPr>
+          <a:xfrm>
+            <a:off x="690080" y="3000000"/>
+            <a:ext cx="1850000" cy="290000"/>
+          </a:xfrm>
+          <a:prstGeom prst="rect">
+            <a:avLst/>
+          </a:prstGeom>
+          <a:noFill/>
+          <a:ln/>
+        </p:spPr>
+        <p:txBody>
+          <a:bodyPr wrap="square" lIns="0" tIns="0" rIns="0" bIns="0" rtlCol="0" anchor="ctr"/>
+          <a:lstStyle/>
+          <a:p>
+            <a:pPr indent="0" marL="0">
+              <a:buNone/>
+            </a:pPr>
+            <a:r>
+              <a:rPr lang="en-US" sz="1100" b="1" dirty="0">
+                <a:solidFill>
+                  <a:srgbClr val="0891B2"/>
+                </a:solidFill>
+                <a:latin typeface="Consolas" pitchFamily="49" charset="0"/>
+              </a:rPr>
+              <a:t>promotions</a:t>
+            </a:r>
+          </a:p>
+        </p:txBody>
+      </p:sp>
+      <p:sp>
+        <p:nvSpPr>
+          <p:cNvPr id="30" name="Rows5"/>
+          <p:cNvSpPr/>
+          <p:nvPr/>
+        </p:nvSpPr>
+        <p:spPr>
+          <a:xfrm>
+            <a:off x="2640080" y="3000000"/>
+            <a:ext cx="900000" cy="290000"/>
+          </a:xfrm>
+          <a:prstGeom prst="rect">
+            <a:avLst/>
+          </a:prstGeom>
+          <a:noFill/>
+          <a:ln/>
+        </p:spPr>
+        <p:txBody>
+          <a:bodyPr wrap="square" lIns="0" tIns="0" rIns="0" bIns="0" rtlCol="0" anchor="ctr"/>
+          <a:lstStyle/>
+          <a:p>
+            <a:pPr indent="0" marL="0">
+              <a:buNone/>
+            </a:pPr>
+            <a:r>
+              <a:rPr lang="en-US" sz="1100" dirty="0">
+                <a:solidFill>
+                  <a:srgbClr val="374151"/>
+                </a:solidFill>
+                <a:latin typeface="Arial" pitchFamily="34" charset="0"/>
+                <a:ea typeface="Arial" pitchFamily="34" charset="-122"/>
+                <a:cs typeface="Arial" pitchFamily="34" charset="-120"/>
+              </a:rPr>
+              <a:t>8</a:t>
+            </a:r>
+            <a:endParaRPr lang="en-US" sz="1100" dirty="0"/>
+          </a:p>
+        </p:txBody>
+      </p:sp>
+      <p:sp>
+        <p:nvSpPr>
+          <p:cNvPr id="31" name="Desc5"/>
+          <p:cNvSpPr/>
+          <p:nvPr/>
+        </p:nvSpPr>
+        <p:spPr>
+          <a:xfrm>
+            <a:off x="3690080" y="3000000"/>
+            <a:ext cx="4810000" cy="290000"/>
+          </a:xfrm>
+          <a:prstGeom prst="rect">
+            <a:avLst/>
+          </a:prstGeom>
+          <a:noFill/>
+          <a:ln/>
+        </p:spPr>
+        <p:txBody>
+          <a:bodyPr wrap="square" lIns="0" tIns="0" rIns="0" bIns="0" rtlCol="0" anchor="ctr"/>
+          <a:lstStyle/>
+          <a:p>
+            <a:pPr indent="0" marL="0">
+              <a:buNone/>
+            </a:pPr>
+            <a:r>
+              <a:rPr lang="en-US" sz="1100" dirty="0">
+                <a:solidFill>
+                  <a:srgbClr val="374151"/>
+                </a:solidFill>
+                <a:latin typeface="Arial" pitchFamily="34" charset="0"/>
+                <a:ea typeface="Arial" pitchFamily="34" charset="-122"/>
+                <a:cs typeface="Arial" pitchFamily="34" charset="-120"/>
+              </a:rPr>
+              <a:t>includes the Comeback 50 voucher campaign</a:t>
+            </a:r>
+            <a:endParaRPr lang="en-US" sz="1100" dirty="0"/>
+          </a:p>
+        </p:txBody>
+      </p:sp>
+      <p:sp>
+        <p:nvSpPr>
+          <p:cNvPr id="32" name="Name6"/>
+          <p:cNvSpPr/>
+          <p:nvPr/>
+        </p:nvSpPr>
+        <p:spPr>
+          <a:xfrm>
+            <a:off x="690080" y="3290000"/>
+            <a:ext cx="1850000" cy="290000"/>
+          </a:xfrm>
+          <a:prstGeom prst="rect">
+            <a:avLst/>
+          </a:prstGeom>
+          <a:noFill/>
+          <a:ln/>
+        </p:spPr>
+        <p:txBody>
+          <a:bodyPr wrap="square" lIns="0" tIns="0" rIns="0" bIns="0" rtlCol="0" anchor="ctr"/>
+          <a:lstStyle/>
+          <a:p>
+            <a:pPr indent="0" marL="0">
+              <a:buNone/>
+            </a:pPr>
+            <a:r>
+              <a:rPr lang="en-US" sz="1100" b="1" dirty="0">
+                <a:solidFill>
+                  <a:srgbClr val="0891B2"/>
+                </a:solidFill>
+                <a:latin typeface="Consolas" pitchFamily="49" charset="0"/>
+              </a:rPr>
+              <a:t>loyalty_events</a:t>
+            </a:r>
+          </a:p>
+        </p:txBody>
+      </p:sp>
+      <p:sp>
+        <p:nvSpPr>
+          <p:cNvPr id="33" name="Rows6"/>
+          <p:cNvSpPr/>
+          <p:nvPr/>
+        </p:nvSpPr>
+        <p:spPr>
+          <a:xfrm>
+            <a:off x="2640080" y="3290000"/>
+            <a:ext cx="900000" cy="290000"/>
+          </a:xfrm>
+          <a:prstGeom prst="rect">
+            <a:avLst/>
+          </a:prstGeom>
+          <a:noFill/>
+          <a:ln/>
+        </p:spPr>
+        <p:txBody>
+          <a:bodyPr wrap="square" lIns="0" tIns="0" rIns="0" bIns="0" rtlCol="0" anchor="ctr"/>
+          <a:lstStyle/>
+          <a:p>
+            <a:pPr indent="0" marL="0">
+              <a:buNone/>
+            </a:pPr>
+            <a:r>
+              <a:rPr lang="en-US" sz="1100" dirty="0">
+                <a:solidFill>
+                  <a:srgbClr val="374151"/>
+                </a:solidFill>
+                <a:latin typeface="Arial" pitchFamily="34" charset="0"/>
+                <a:ea typeface="Arial" pitchFamily="34" charset="-122"/>
+                <a:cs typeface="Arial" pitchFamily="34" charset="-120"/>
+              </a:rPr>
+              <a:t>~273,000</a:t>
+            </a:r>
+            <a:endParaRPr lang="en-US" sz="1100" dirty="0"/>
+          </a:p>
+        </p:txBody>
+      </p:sp>
+      <p:sp>
+        <p:nvSpPr>
+          <p:cNvPr id="34" name="Desc6"/>
+          <p:cNvSpPr/>
+          <p:nvPr/>
+        </p:nvSpPr>
+        <p:spPr>
+          <a:xfrm>
+            <a:off x="3690080" y="3290000"/>
+            <a:ext cx="4810000" cy="290000"/>
+          </a:xfrm>
+          <a:prstGeom prst="rect">
+            <a:avLst/>
+          </a:prstGeom>
+          <a:noFill/>
+          <a:ln/>
+        </p:spPr>
+        <p:txBody>
+          <a:bodyPr wrap="square" lIns="0" tIns="0" rIns="0" bIns="0" rtlCol="0" anchor="ctr"/>
+          <a:lstStyle/>
+          <a:p>
+            <a:pPr indent="0" marL="0">
+              <a:buNone/>
+            </a:pPr>
+            <a:r>
+              <a:rPr lang="en-US" sz="1100" dirty="0">
+                <a:solidFill>
+                  <a:srgbClr val="374151"/>
+                </a:solidFill>
+                <a:latin typeface="Arial" pitchFamily="34" charset="0"/>
+                <a:ea typeface="Arial" pitchFamily="34" charset="-122"/>
+                <a:cs typeface="Arial" pitchFamily="34" charset="-120"/>
+              </a:rPr>
+              <a:t>per-customer event log: signup / visit / lapse</a:t>
+            </a:r>
+            <a:endParaRPr lang="en-US" sz="1100" dirty="0"/>
+          </a:p>
+        </p:txBody>
+      </p:sp>
+      <p:sp>
+        <p:nvSpPr>
+          <p:cNvPr id="35" name="RowBg7"/>
+          <p:cNvSpPr/>
+          <p:nvPr/>
+        </p:nvSpPr>
+        <p:spPr>
+          <a:xfrm>
+            <a:off x="640080" y="3580000"/>
+            <a:ext cx="7860000" cy="290000"/>
+          </a:xfrm>
+          <a:prstGeom prst="rect">
+            <a:avLst/>
+          </a:prstGeom>
+          <a:solidFill>
+            <a:srgbClr val="F3F4F6"/>
+          </a:solidFill>
+          <a:ln/>
+        </p:spPr>
+      </p:sp>
+      <p:sp>
+        <p:nvSpPr>
+          <p:cNvPr id="36" name="Name7"/>
+          <p:cNvSpPr/>
+          <p:nvPr/>
+        </p:nvSpPr>
+        <p:spPr>
+          <a:xfrm>
+            <a:off x="690080" y="3580000"/>
+            <a:ext cx="1850000" cy="290000"/>
+          </a:xfrm>
+          <a:prstGeom prst="rect">
+            <a:avLst/>
+          </a:prstGeom>
+          <a:noFill/>
+          <a:ln/>
+        </p:spPr>
+        <p:txBody>
+          <a:bodyPr wrap="square" lIns="0" tIns="0" rIns="0" bIns="0" rtlCol="0" anchor="ctr"/>
+          <a:lstStyle/>
+          <a:p>
+            <a:pPr indent="0" marL="0">
+              <a:buNone/>
+            </a:pPr>
+            <a:r>
+              <a:rPr lang="en-US" sz="1100" b="1" dirty="0">
+                <a:solidFill>
+                  <a:srgbClr val="0891B2"/>
+                </a:solidFill>
+                <a:latin typeface="Consolas" pitchFamily="49" charset="0"/>
+              </a:rPr>
+              <a:t>campaign_responses</a:t>
+            </a:r>
+          </a:p>
+        </p:txBody>
+      </p:sp>
+      <p:sp>
+        <p:nvSpPr>
+          <p:cNvPr id="37" name="Rows7"/>
+          <p:cNvSpPr/>
+          <p:nvPr/>
+        </p:nvSpPr>
+        <p:spPr>
+          <a:xfrm>
+            <a:off x="2640080" y="3580000"/>
+            <a:ext cx="900000" cy="290000"/>
+          </a:xfrm>
+          <a:prstGeom prst="rect">
+            <a:avLst/>
+          </a:prstGeom>
+          <a:noFill/>
+          <a:ln/>
+        </p:spPr>
+        <p:txBody>
+          <a:bodyPr wrap="square" lIns="0" tIns="0" rIns="0" bIns="0" rtlCol="0" anchor="ctr"/>
+          <a:lstStyle/>
+          <a:p>
+            <a:pPr indent="0" marL="0">
+              <a:buNone/>
+            </a:pPr>
+            <a:r>
+              <a:rPr lang="en-US" sz="1100" dirty="0">
+                <a:solidFill>
+                  <a:srgbClr val="374151"/>
+                </a:solidFill>
+                <a:latin typeface="Arial" pitchFamily="34" charset="0"/>
+                <a:ea typeface="Arial" pitchFamily="34" charset="-122"/>
+                <a:cs typeface="Arial" pitchFamily="34" charset="-120"/>
+              </a:rPr>
+              <a:t>874</a:t>
+            </a:r>
+            <a:endParaRPr lang="en-US" sz="1100" dirty="0"/>
+          </a:p>
+        </p:txBody>
+      </p:sp>
+      <p:sp>
+        <p:nvSpPr>
+          <p:cNvPr id="38" name="Desc7"/>
+          <p:cNvSpPr/>
+          <p:nvPr/>
+        </p:nvSpPr>
+        <p:spPr>
+          <a:xfrm>
+            <a:off x="3690080" y="3580000"/>
+            <a:ext cx="4810000" cy="290000"/>
+          </a:xfrm>
+          <a:prstGeom prst="rect">
+            <a:avLst/>
+          </a:prstGeom>
+          <a:noFill/>
+          <a:ln/>
+        </p:spPr>
+        <p:txBody>
+          <a:bodyPr wrap="square" lIns="0" tIns="0" rIns="0" bIns="0" rtlCol="0" anchor="ctr"/>
+          <a:lstStyle/>
+          <a:p>
+            <a:pPr indent="0" marL="0">
+              <a:buNone/>
+            </a:pPr>
+            <a:r>
+              <a:rPr lang="en-US" sz="1100" dirty="0">
+                <a:solidFill>
+                  <a:srgbClr val="374151"/>
+                </a:solidFill>
+                <a:latin typeface="Arial" pitchFamily="34" charset="0"/>
+                <a:ea typeface="Arial" pitchFamily="34" charset="-122"/>
+                <a:cs typeface="Arial" pitchFamily="34" charset="-120"/>
+              </a:rPr>
+              <a:t>Comeback 50 sent to lapsed members; ~11% responded</a:t>
+            </a:r>
+            <a:endParaRPr lang="en-US" sz="1100" dirty="0"/>
+          </a:p>
+        </p:txBody>
+      </p:sp>
+      <p:sp>
+        <p:nvSpPr>
+          <p:cNvPr id="39" name="Name8"/>
+          <p:cNvSpPr/>
+          <p:nvPr/>
+        </p:nvSpPr>
+        <p:spPr>
+          <a:xfrm>
+            <a:off x="690080" y="3870000"/>
+            <a:ext cx="1850000" cy="290000"/>
+          </a:xfrm>
+          <a:prstGeom prst="rect">
+            <a:avLst/>
+          </a:prstGeom>
+          <a:noFill/>
+          <a:ln/>
+        </p:spPr>
+        <p:txBody>
+          <a:bodyPr wrap="square" lIns="0" tIns="0" rIns="0" bIns="0" rtlCol="0" anchor="ctr"/>
+          <a:lstStyle/>
+          <a:p>
+            <a:pPr indent="0" marL="0">
+              <a:buNone/>
+            </a:pPr>
+            <a:r>
+              <a:rPr lang="en-US" sz="1100" b="1" dirty="0">
+                <a:solidFill>
+                  <a:srgbClr val="0891B2"/>
+                </a:solidFill>
+                <a:latin typeface="Consolas" pitchFamily="49" charset="0"/>
+              </a:rPr>
+              <a:t>reviews</a:t>
+            </a:r>
+          </a:p>
+        </p:txBody>
+      </p:sp>
+      <p:sp>
+        <p:nvSpPr>
+          <p:cNvPr id="40" name="Rows8"/>
+          <p:cNvSpPr/>
+          <p:nvPr/>
+        </p:nvSpPr>
+        <p:spPr>
+          <a:xfrm>
+            <a:off x="2640080" y="3870000"/>
+            <a:ext cx="900000" cy="290000"/>
+          </a:xfrm>
+          <a:prstGeom prst="rect">
+            <a:avLst/>
+          </a:prstGeom>
+          <a:noFill/>
+          <a:ln/>
+        </p:spPr>
+        <p:txBody>
+          <a:bodyPr wrap="square" lIns="0" tIns="0" rIns="0" bIns="0" rtlCol="0" anchor="ctr"/>
+          <a:lstStyle/>
+          <a:p>
+            <a:pPr indent="0" marL="0">
+              <a:buNone/>
+            </a:pPr>
+            <a:r>
+              <a:rPr lang="en-US" sz="1100" dirty="0">
+                <a:solidFill>
+                  <a:srgbClr val="374151"/>
+                </a:solidFill>
+                <a:latin typeface="Arial" pitchFamily="34" charset="0"/>
+                <a:ea typeface="Arial" pitchFamily="34" charset="-122"/>
+                <a:cs typeface="Arial" pitchFamily="34" charset="-120"/>
+              </a:rPr>
+              <a:t>1,835</a:t>
+            </a:r>
+            <a:endParaRPr lang="en-US" sz="1100" dirty="0"/>
+          </a:p>
+        </p:txBody>
+      </p:sp>
+      <p:sp>
+        <p:nvSpPr>
+          <p:cNvPr id="41" name="Desc8"/>
+          <p:cNvSpPr/>
+          <p:nvPr/>
+        </p:nvSpPr>
+        <p:spPr>
+          <a:xfrm>
+            <a:off x="3690080" y="3870000"/>
+            <a:ext cx="4810000" cy="290000"/>
+          </a:xfrm>
+          <a:prstGeom prst="rect">
+            <a:avLst/>
+          </a:prstGeom>
+          <a:noFill/>
+          <a:ln/>
+        </p:spPr>
+        <p:txBody>
+          <a:bodyPr wrap="square" lIns="0" tIns="0" rIns="0" bIns="0" rtlCol="0" anchor="ctr"/>
+          <a:lstStyle/>
+          <a:p>
+            <a:pPr indent="0" marL="0">
+              <a:buNone/>
+            </a:pPr>
+            <a:r>
+              <a:rPr lang="en-US" sz="1100" dirty="0">
+                <a:solidFill>
+                  <a:srgbClr val="374151"/>
+                </a:solidFill>
+                <a:latin typeface="Arial" pitchFamily="34" charset="0"/>
+                <a:ea typeface="Arial" pitchFamily="34" charset="-122"/>
+                <a:cs typeface="Arial" pitchFamily="34" charset="-120"/>
+              </a:rPr>
+              <a:t>Thai + English mixed with rating + sentiment label</a:t>
+            </a:r>
+            <a:endParaRPr lang="en-US" sz="1100" dirty="0"/>
+          </a:p>
+        </p:txBody>
+      </p:sp>
+      <p:sp>
+        <p:nvSpPr>
+          <p:cNvPr id="42" name="Caption"/>
+          <p:cNvSpPr/>
+          <p:nvPr/>
+        </p:nvSpPr>
+        <p:spPr>
+          <a:xfrm>
+            <a:off x="640080" y="4240000"/>
+            <a:ext cx="7860000" cy="280000"/>
+          </a:xfrm>
+          <a:prstGeom prst="rect">
+            <a:avLst/>
+          </a:prstGeom>
+          <a:noFill/>
+          <a:ln/>
+        </p:spPr>
+        <p:txBody>
+          <a:bodyPr wrap="square" lIns="0" tIns="0" rIns="0" bIns="0" rtlCol="0" anchor="t"/>
+          <a:lstStyle/>
+          <a:p>
+            <a:pPr indent="0" marL="0">
+              <a:buNone/>
+            </a:pPr>
+            <a:r>
+              <a:rPr lang="en-US" sz="1100" i="1" dirty="0">
+                <a:solidFill>
+                  <a:srgbClr val="6B7280"/>
+                </a:solidFill>
+                <a:latin typeface="Arial" pitchFamily="34" charset="0"/>
+                <a:ea typeface="Arial" pitchFamily="34" charset="-122"/>
+                <a:cs typeface="Arial" pitchFamily="34" charset="-120"/>
+              </a:rPr>
+              <a:t>All tables join on branch_id / customer_id / product_id / promo_id.</a:t>
+            </a:r>
+            <a:endParaRPr lang="en-US" sz="1100" dirty="0"/>
+          </a:p>
+        </p:txBody>
+      </p:sp>
+    </p:spTree>
+  </p:cSld>
+  <p:clrMapOvr>
+    <a:masterClrMapping/>
+  </p:clrMapOvr>
+</p:sld>
+</file>
+
 <file path=ppt/slides/slide4.xml><?xml version="1.0" encoding="utf-8"?>
 <p:sld xmlns:a="http://schemas.openxmlformats.org/drawingml/2006/main" xmlns:r="http://schemas.openxmlformats.org/officeDocument/2006/relationships" xmlns:p="http://schemas.openxmlformats.org/presentationml/2006/main">
   <p:cSld name="Slide 4">

</xml_diff>